<commit_message>
M19: Sim-Review umgesetzt (sim_review true, Inhalt aktualisiert)
Co-Authored-By: Claude Opus 4.8 <noreply@anthropic.com>
</commit_message>
<xml_diff>
--- a/protected-downloads/praesentation/M19.pptx
+++ b/protected-downloads/praesentation/M19.pptx
@@ -8229,7 +8229,7 @@
                 </a:solidFill>
                 <a:latin typeface="Arial"/>
               </a:rPr>
-              <a:t>▸  Explizites von implizitem Wissen unterscheiden und ungenutzte Transferbereiche identifizieren</a:t>
+              <a:t>▸  Explizites und implizites Wissen im Beratungsalltag analysieren und ungenutzte Transferbereiche identifizieren</a:t>
             </a:r>
           </a:p>
           <a:p>
@@ -8753,7 +8753,7 @@
                 </a:solidFill>
                 <a:latin typeface="Consolas"/>
               </a:rPr>
-              <a:t>00:45       </a:t>
+              <a:t>00:40       </a:t>
             </a:r>
             <a:r>
               <a:rPr sz="1200" b="1">

</xml_diff>

<commit_message>
M-Track Batch 3: M19 Deck (Web/Workbook)
Co-Authored-By: Claude Fable 5 <noreply@anthropic.com>
</commit_message>
<xml_diff>
--- a/protected-downloads/praesentation/M19.pptx
+++ b/protected-downloads/praesentation/M19.pptx
@@ -19,7 +19,6 @@
     <p:sldId id="267" r:id="rId19"/>
     <p:sldId id="268" r:id="rId20"/>
     <p:sldId id="269" r:id="rId21"/>
-    <p:sldId id="270" r:id="rId22"/>
   </p:sldIdLst>
   <p:sldSz cx="12188952" cy="6858000" type="screen4x3"/>
   <p:notesSz cx="6858000" cy="9144000"/>
@@ -586,7 +585,7 @@
           <a:lstStyle/>
           <a:p>
             <a:r>
-              <a:t>Siehe Trainerhandbuch (Sektion 3) für Moderationshinweise, Timing und erwartete Teilnehmerreaktionen.</a:t>
+              <a:t>Einstieg: „Was wüsste Ihr Team nicht mehr, wenn Ihr erfahrenster Berater morgen ginge?"</a:t>
             </a:r>
           </a:p>
         </p:txBody>
@@ -656,7 +655,7 @@
           <a:lstStyle/>
           <a:p>
             <a:r>
-              <a:t>Siehe Trainerhandbuch (Sektion 3) für Moderationshinweise, Timing und erwartete Teilnehmerreaktionen.</a:t>
+              <a:t>SECI (Nonaka &amp; Takeuchi) zeigt, warum reines Dokumentieren nicht reicht – Wissen muss zirkulieren.</a:t>
             </a:r>
           </a:p>
         </p:txBody>
@@ -726,7 +725,7 @@
           <a:lstStyle/>
           <a:p>
             <a:r>
-              <a:t>Moderation (HB Sec 3): Kein fertiges Tool – Pinnwand und Moderationskarten reichen Anleitung: Jede Person des Teams als Feld, darunter ihre Kernwissensgebiete notieren; Lücken rot markieren Häufiges Ergebnis: TN erkennen, dass Schlüsselwissen bei einer Person liegt (Single Point of Failure) Für neue Berater (&lt; 3 Jahre im Team): Wenn TN ihr Team noch nicht gut kennen, umformulieren: „Tragen Sie ein, was Sie wissen – und markieren Sie rot, was Sie nicht wissen. Dieses Ergebnis ist genauso wertvoll: Es zeigt die Wissenstransparenz-Lücke in Ihrem Team." Das „Nicht-Wissen" ist kein Scheitern, sondern das ehrlichste Ergebnis der Übung.</a:t>
+              <a:t>Kolb verbindet die Transfermethoden: jede Methode setzt an einer anderen Stelle des Zyklus an.</a:t>
             </a:r>
           </a:p>
         </p:txBody>
@@ -796,7 +795,7 @@
           <a:lstStyle/>
           <a:p>
             <a:r>
-              <a:t>Siehe Trainerhandbuch (Sektion 3) für Moderationshinweise, Timing und erwartete Teilnehmerreaktionen.</a:t>
+              <a:t>Jede Methode ist niederschwellig und alltagstauglich; typische Transferbarrieren (Zeit, Konkurrenz, Scheu) gezielt adressieren.</a:t>
             </a:r>
           </a:p>
         </p:txBody>
@@ -866,7 +865,7 @@
           <a:lstStyle/>
           <a:p>
             <a:r>
-              <a:t>Siehe Trainerhandbuch (Sektion 3) für Moderationshinweise, Timing und erwartete Teilnehmerreaktionen.</a:t>
+              <a:t>Fall Team Ostbayern: verteiltes Wissen, kein Format zum Teilen. Lösung: passende Methode zur Barriere wählen, verbindlich terminieren.</a:t>
             </a:r>
           </a:p>
         </p:txBody>
@@ -936,7 +935,7 @@
           <a:lstStyle/>
           <a:p>
             <a:r>
-              <a:t>Siehe Trainerhandbuch (Sektion 3) für Moderationshinweise, Timing und erwartete Teilnehmerreaktionen.</a:t>
+              <a:t>Überleitung zum Maßnahmenplan und Selbstcheck.</a:t>
             </a:r>
           </a:p>
         </p:txBody>
@@ -1006,7 +1005,7 @@
           <a:lstStyle/>
           <a:p>
             <a:r>
-              <a:t>Siehe Trainerhandbuch (Sektion 3) für Moderationshinweise, Timing und erwartete Teilnehmerreaktionen.</a:t>
+              <a:t>Maßnahmenplan und Selbstcheck als Transferanker.</a:t>
             </a:r>
           </a:p>
         </p:txBody>
@@ -4824,7 +4823,7 @@
                 </a:solidFill>
                 <a:latin typeface="Arial"/>
               </a:rPr>
-              <a:t>Methode 4: Lunch-and-Learn (15 Minuten)</a:t>
+              <a:t>Fünf bewährte Transfermethoden im FK-Kontext</a:t>
             </a:r>
           </a:p>
         </p:txBody>
@@ -4850,6 +4849,25 @@
             <a:spAutoFit/>
           </a:bodyPr>
           <a:lstStyle/>
+          <a:p>
+            <a:pPr marL="177800" indent="-177800">
+              <a:spcBef>
+                <a:spcPts val="600"/>
+              </a:spcBef>
+              <a:spcAft>
+                <a:spcPts val="200"/>
+              </a:spcAft>
+            </a:pPr>
+            <a:r>
+              <a:rPr sz="1200" i="1">
+                <a:solidFill>
+                  <a:srgbClr val="3D5466"/>
+                </a:solidFill>
+                <a:latin typeface="Arial"/>
+              </a:rPr>
+              <a:t>→  Wissenstransfer braucht Formate – fünf niederschwellige Methoden, die im Alltag funktionieren.</a:t>
+            </a:r>
+          </a:p>
           <a:p>
             <a:pPr marL="190500" indent="-190500">
               <a:spcBef>
@@ -4866,7 +4884,7 @@
                 </a:solidFill>
                 <a:latin typeface="Arial"/>
               </a:rPr>
-              <a:t>▸  Was: Kurzes, informelles Wissensformat – ein Berater erklärt an einem konkreten Beispiel eine Technik oder ein Konzept.</a:t>
+              <a:t>▸  Tandem-Kundenbesuch, strukturierte Fallbesprechung, Wissenslandkarte.</a:t>
             </a:r>
           </a:p>
           <a:p>
@@ -4885,26 +4903,7 @@
                 </a:solidFill>
                 <a:latin typeface="Arial"/>
               </a:rPr>
-              <a:t>▸  Wann: Spontan oder geplant, 1–2× pro Monat.</a:t>
-            </a:r>
-          </a:p>
-          <a:p>
-            <a:pPr marL="190500" indent="-190500">
-              <a:spcBef>
-                <a:spcPts val="400"/>
-              </a:spcBef>
-              <a:spcAft>
-                <a:spcPts val="200"/>
-              </a:spcAft>
-            </a:pPr>
-            <a:r>
-              <a:rPr sz="1300">
-                <a:solidFill>
-                  <a:srgbClr val="3D5466"/>
-                </a:solidFill>
-                <a:latin typeface="Arial"/>
-              </a:rPr>
-              <a:t>▸  Qualitätsfaktor: Keine Präsentation, keine Vorbereitung – nur Erzählen + Fragen.</a:t>
+              <a:t>▸  Lunch-and-Learn (15 Minuten), Reverse Mentoring – auch für hybride Teams.</a:t>
             </a:r>
           </a:p>
         </p:txBody>
@@ -5020,7 +5019,7 @@
             <a:avLst/>
           </a:prstGeom>
           <a:solidFill>
-            <a:srgbClr val="EDEDF3"/>
+            <a:srgbClr val="1F2C56"/>
           </a:solidFill>
           <a:ln>
             <a:noFill/>
@@ -5050,57 +5049,14 @@
       </p:sp>
       <p:sp>
         <p:nvSpPr>
-          <p:cNvPr id="3" name="Rectangle 2"/>
-          <p:cNvSpPr/>
-          <p:nvPr/>
-        </p:nvSpPr>
-        <p:spPr>
-          <a:xfrm>
-            <a:off x="0" y="0"/>
-            <a:ext cx="12188952" cy="50292"/>
-          </a:xfrm>
-          <a:prstGeom prst="rect">
-            <a:avLst/>
-          </a:prstGeom>
-          <a:solidFill>
-            <a:srgbClr val="1F2C56"/>
-          </a:solidFill>
-          <a:ln>
-            <a:noFill/>
-          </a:ln>
-        </p:spPr>
-        <p:style>
-          <a:lnRef idx="1">
-            <a:schemeClr val="accent1"/>
-          </a:lnRef>
-          <a:fillRef idx="3">
-            <a:schemeClr val="accent1"/>
-          </a:fillRef>
-          <a:effectRef idx="2">
-            <a:schemeClr val="accent1"/>
-          </a:effectRef>
-          <a:fontRef idx="minor">
-            <a:schemeClr val="lt1"/>
-          </a:fontRef>
-        </p:style>
-        <p:txBody>
-          <a:bodyPr rtlCol="0" anchor="ctr"/>
-          <a:lstStyle/>
-          <a:p>
-            <a:pPr algn="ctr"/>
-          </a:p>
-        </p:txBody>
-      </p:sp>
-      <p:sp>
-        <p:nvSpPr>
-          <p:cNvPr id="4" name="TextBox 3"/>
+          <p:cNvPr id="3" name="TextBox 2"/>
           <p:cNvSpPr txBox="1"/>
           <p:nvPr/>
         </p:nvSpPr>
         <p:spPr>
           <a:xfrm>
-            <a:off x="685800" y="109728"/>
-            <a:ext cx="10817352" cy="228600"/>
+            <a:off x="685800" y="2377440"/>
+            <a:ext cx="10817352" cy="365760"/>
           </a:xfrm>
           <a:prstGeom prst="rect">
             <a:avLst/>
@@ -5115,70 +5071,27 @@
           <a:p>
             <a:pPr algn="l"/>
             <a:r>
-              <a:rPr sz="750">
-                <a:solidFill>
-                  <a:srgbClr val="78808C"/>
+              <a:rPr sz="1200">
+                <a:solidFill>
+                  <a:srgbClr val="D9C089"/>
                 </a:solidFill>
                 <a:latin typeface="Consolas"/>
               </a:rPr>
-              <a:t>M19  ·  INHALT</a:t>
-            </a:r>
-          </a:p>
-        </p:txBody>
-      </p:sp>
-      <p:sp>
-        <p:nvSpPr>
-          <p:cNvPr id="5" name="Rectangle 4"/>
+              <a:t>FALLARBEIT</a:t>
+            </a:r>
+          </a:p>
+        </p:txBody>
+      </p:sp>
+      <p:sp>
+        <p:nvSpPr>
+          <p:cNvPr id="4" name="Rectangle 3"/>
           <p:cNvSpPr/>
           <p:nvPr/>
         </p:nvSpPr>
         <p:spPr>
           <a:xfrm>
-            <a:off x="0" y="1234440"/>
-            <a:ext cx="12188952" cy="12700"/>
-          </a:xfrm>
-          <a:prstGeom prst="rect">
-            <a:avLst/>
-          </a:prstGeom>
-          <a:solidFill>
-            <a:srgbClr val="D8DFE4"/>
-          </a:solidFill>
-          <a:ln>
-            <a:noFill/>
-          </a:ln>
-        </p:spPr>
-        <p:style>
-          <a:lnRef idx="1">
-            <a:schemeClr val="accent1"/>
-          </a:lnRef>
-          <a:fillRef idx="3">
-            <a:schemeClr val="accent1"/>
-          </a:fillRef>
-          <a:effectRef idx="2">
-            <a:schemeClr val="accent1"/>
-          </a:effectRef>
-          <a:fontRef idx="minor">
-            <a:schemeClr val="lt1"/>
-          </a:fontRef>
-        </p:style>
-        <p:txBody>
-          <a:bodyPr rtlCol="0" anchor="ctr"/>
-          <a:lstStyle/>
-          <a:p>
-            <a:pPr algn="ctr"/>
-          </a:p>
-        </p:txBody>
-      </p:sp>
-      <p:sp>
-        <p:nvSpPr>
-          <p:cNvPr id="6" name="Rectangle 5"/>
-          <p:cNvSpPr/>
-          <p:nvPr/>
-        </p:nvSpPr>
-        <p:spPr>
-          <a:xfrm>
-            <a:off x="685800" y="502920"/>
-            <a:ext cx="36576" cy="658368"/>
+            <a:off x="685800" y="2788920"/>
+            <a:ext cx="548640" cy="38100"/>
           </a:xfrm>
           <a:prstGeom prst="rect">
             <a:avLst/>
@@ -5214,14 +5127,14 @@
       </p:sp>
       <p:sp>
         <p:nvSpPr>
-          <p:cNvPr id="7" name="TextBox 6"/>
+          <p:cNvPr id="5" name="TextBox 4"/>
           <p:cNvSpPr txBox="1"/>
           <p:nvPr/>
         </p:nvSpPr>
         <p:spPr>
           <a:xfrm>
-            <a:off x="813816" y="502920"/>
-            <a:ext cx="10634472" cy="685800"/>
+            <a:off x="685800" y="3017520"/>
+            <a:ext cx="10817352" cy="1463040"/>
           </a:xfrm>
           <a:prstGeom prst="rect">
             <a:avLst/>
@@ -5236,27 +5149,27 @@
           <a:p>
             <a:pPr algn="l"/>
             <a:r>
-              <a:rPr sz="2400" b="1" i="0">
-                <a:solidFill>
-                  <a:srgbClr val="1F2C56"/>
+              <a:rPr sz="4000" b="1" i="0">
+                <a:solidFill>
+                  <a:srgbClr val="FFFFFF"/>
                 </a:solidFill>
                 <a:latin typeface="Arial"/>
               </a:rPr>
-              <a:t>Hinweis: Hybride und standortverteilte Teams</a:t>
-            </a:r>
-          </a:p>
-        </p:txBody>
-      </p:sp>
-      <p:sp>
-        <p:nvSpPr>
-          <p:cNvPr id="8" name="TextBox 7"/>
+              <a:t>Praxiscase Team Ostbayern</a:t>
+            </a:r>
+          </a:p>
+        </p:txBody>
+      </p:sp>
+      <p:sp>
+        <p:nvSpPr>
+          <p:cNvPr id="6" name="TextBox 5"/>
           <p:cNvSpPr txBox="1"/>
           <p:nvPr/>
         </p:nvSpPr>
         <p:spPr>
           <a:xfrm>
-            <a:off x="685800" y="1417320"/>
-            <a:ext cx="10817352" cy="4892040"/>
+            <a:off x="685800" y="4480560"/>
+            <a:ext cx="8653881" cy="1280160"/>
           </a:xfrm>
           <a:prstGeom prst="rect">
             <a:avLst/>
@@ -5264,84 +5177,34 @@
           <a:noFill/>
         </p:spPr>
         <p:txBody>
-          <a:bodyPr wrap="square" anchor="ctr">
+          <a:bodyPr wrap="square">
             <a:spAutoFit/>
           </a:bodyPr>
           <a:lstStyle/>
           <a:p>
-            <a:pPr marL="190500" indent="-190500">
-              <a:spcBef>
-                <a:spcPts val="400"/>
-              </a:spcBef>
-              <a:spcAft>
-                <a:spcPts val="200"/>
-              </a:spcAft>
-            </a:pPr>
-            <a:r>
-              <a:rPr sz="1300">
-                <a:solidFill>
-                  <a:srgbClr val="3D5466"/>
+            <a:pPr algn="l"/>
+            <a:r>
+              <a:rPr sz="1600" b="0" i="0">
+                <a:solidFill>
+                  <a:srgbClr val="C8D2E6"/>
                 </a:solidFill>
                 <a:latin typeface="Arial"/>
               </a:rPr>
-              <a:t>▸  Viele VR-Bank-FK-Teams arbeiten inzwischen über mehrere Geschäftsstellen verteilt oder hybrid. Die o.g. Methoden funktionieren auch auf Distanz – mit kleinen Anpassungen:</a:t>
-            </a:r>
-          </a:p>
-        </p:txBody>
-      </p:sp>
-      <p:sp>
-        <p:nvSpPr>
-          <p:cNvPr id="9" name="Rectangle 8"/>
-          <p:cNvSpPr/>
-          <p:nvPr/>
-        </p:nvSpPr>
-        <p:spPr>
-          <a:xfrm>
-            <a:off x="0" y="6510528"/>
-            <a:ext cx="12188952" cy="347472"/>
-          </a:xfrm>
-          <a:prstGeom prst="rect">
-            <a:avLst/>
-          </a:prstGeom>
-          <a:solidFill>
-            <a:srgbClr val="0A1937"/>
-          </a:solidFill>
-          <a:ln>
-            <a:noFill/>
-          </a:ln>
-        </p:spPr>
-        <p:style>
-          <a:lnRef idx="1">
-            <a:schemeClr val="accent1"/>
-          </a:lnRef>
-          <a:fillRef idx="3">
-            <a:schemeClr val="accent1"/>
-          </a:fillRef>
-          <a:effectRef idx="2">
-            <a:schemeClr val="accent1"/>
-          </a:effectRef>
-          <a:fontRef idx="minor">
-            <a:schemeClr val="lt1"/>
-          </a:fontRef>
-        </p:style>
-        <p:txBody>
-          <a:bodyPr rtlCol="0" anchor="ctr"/>
-          <a:lstStyle/>
-          <a:p>
-            <a:pPr algn="ctr"/>
-          </a:p>
-        </p:txBody>
-      </p:sp>
-      <p:sp>
-        <p:nvSpPr>
-          <p:cNvPr id="10" name="TextBox 9"/>
+              <a:t>Einen konkreten Wissenstransfer-Plan für das eigene Team entwerfen.</a:t>
+            </a:r>
+          </a:p>
+        </p:txBody>
+      </p:sp>
+      <p:sp>
+        <p:nvSpPr>
+          <p:cNvPr id="7" name="TextBox 6"/>
           <p:cNvSpPr txBox="1"/>
           <p:nvPr/>
         </p:nvSpPr>
         <p:spPr>
           <a:xfrm>
-            <a:off x="685800" y="6583680"/>
-            <a:ext cx="6490411" cy="256032"/>
+            <a:off x="685800" y="6355080"/>
+            <a:ext cx="10817352" cy="274320"/>
           </a:xfrm>
           <a:prstGeom prst="rect">
             <a:avLst/>
@@ -5358,7 +5221,7 @@
             <a:r>
               <a:rPr sz="700">
                 <a:solidFill>
-                  <a:srgbClr val="A0B4D2"/>
+                  <a:srgbClr val="8CA0C3"/>
                 </a:solidFill>
                 <a:latin typeface="Consolas"/>
               </a:rPr>
@@ -5501,7 +5364,7 @@
                 </a:solidFill>
                 <a:latin typeface="Consolas"/>
               </a:rPr>
-              <a:t>M19  ·  INHALT</a:t>
+              <a:t>M19  ·  ARBEITSBLATT</a:t>
             </a:r>
           </a:p>
         </p:txBody>
@@ -5622,7 +5485,7 @@
                 </a:solidFill>
                 <a:latin typeface="Arial"/>
               </a:rPr>
-              <a:t>Methode 5: Reverse Mentoring</a:t>
+              <a:t>Wissenstransfer im Team bearbeiten</a:t>
             </a:r>
           </a:p>
         </p:txBody>
@@ -5635,8 +5498,8 @@
         </p:nvSpPr>
         <p:spPr>
           <a:xfrm>
-            <a:off x="685800" y="1417320"/>
-            <a:ext cx="10817352" cy="4892040"/>
+            <a:off x="685800" y="1554480"/>
+            <a:ext cx="10817352" cy="3840480"/>
           </a:xfrm>
           <a:prstGeom prst="rect">
             <a:avLst/>
@@ -5658,13 +5521,13 @@
               </a:spcAft>
             </a:pPr>
             <a:r>
-              <a:rPr sz="1300">
+              <a:rPr sz="1400">
                 <a:solidFill>
                   <a:srgbClr val="3D5466"/>
                 </a:solidFill>
                 <a:latin typeface="Arial"/>
               </a:rPr>
-              <a:t>▸  Was: Jüngere/neuere Berater unterweisen erfahrene Berater in Digitalthemen oder neuen Systemfunktionen.</a:t>
+              <a:t>▸  Erstellen Sie Ihren Wissenslandkarten-Steckbrief: Was können nur Sie? (AB-1)</a:t>
             </a:r>
           </a:p>
           <a:p>
@@ -5677,13 +5540,13 @@
               </a:spcAft>
             </a:pPr>
             <a:r>
-              <a:rPr sz="1300">
+              <a:rPr sz="1400">
                 <a:solidFill>
                   <a:srgbClr val="3D5466"/>
                 </a:solidFill>
                 <a:latin typeface="Arial"/>
               </a:rPr>
-              <a:t>▸  Wann: Bei Einführung neuer Tools (z.B. agree-Updates, CRM-Erweiterungen).</a:t>
+              <a:t>▸  Bereiten Sie eine strukturierte Fallbesprechung vor (AB-2).</a:t>
             </a:r>
           </a:p>
           <a:p>
@@ -5696,191 +5559,98 @@
               </a:spcAft>
             </a:pPr>
             <a:r>
-              <a:rPr sz="1300">
+              <a:rPr sz="1400">
                 <a:solidFill>
                   <a:srgbClr val="3D5466"/>
                 </a:solidFill>
                 <a:latin typeface="Arial"/>
               </a:rPr>
-              <a:t>▸  Nutzen: Durchbricht die Hierarchie als Wissensbarriere; wertet beide Seiten auf.</a:t>
-            </a:r>
-          </a:p>
-          <a:p>
-            <a:pPr marL="190500" indent="-190500">
-              <a:spcBef>
-                <a:spcPts val="400"/>
-              </a:spcBef>
-              <a:spcAft>
-                <a:spcPts val="200"/>
-              </a:spcAft>
-            </a:pPr>
-            <a:r>
-              <a:rPr sz="1300">
-                <a:solidFill>
-                  <a:srgbClr val="3D5466"/>
+              <a:t>▸  Entwerfen Sie einen Wissenstransfer-Maßnahmenplan für Ihr Team (AB-3).</a:t>
+            </a:r>
+          </a:p>
+        </p:txBody>
+      </p:sp>
+      <p:sp>
+        <p:nvSpPr>
+          <p:cNvPr id="9" name="Rectangle 8"/>
+          <p:cNvSpPr/>
+          <p:nvPr/>
+        </p:nvSpPr>
+        <p:spPr>
+          <a:xfrm>
+            <a:off x="685800" y="5486400"/>
+            <a:ext cx="10817352" cy="640080"/>
+          </a:xfrm>
+          <a:prstGeom prst="rect">
+            <a:avLst/>
+          </a:prstGeom>
+          <a:solidFill>
+            <a:srgbClr val="1F2C56"/>
+          </a:solidFill>
+          <a:ln>
+            <a:noFill/>
+          </a:ln>
+        </p:spPr>
+        <p:style>
+          <a:lnRef idx="1">
+            <a:schemeClr val="accent1"/>
+          </a:lnRef>
+          <a:fillRef idx="3">
+            <a:schemeClr val="accent1"/>
+          </a:fillRef>
+          <a:effectRef idx="2">
+            <a:schemeClr val="accent1"/>
+          </a:effectRef>
+          <a:fontRef idx="minor">
+            <a:schemeClr val="lt1"/>
+          </a:fontRef>
+        </p:style>
+        <p:txBody>
+          <a:bodyPr rtlCol="0" anchor="ctr"/>
+          <a:lstStyle/>
+          <a:p>
+            <a:pPr algn="ctr"/>
+          </a:p>
+        </p:txBody>
+      </p:sp>
+      <p:sp>
+        <p:nvSpPr>
+          <p:cNvPr id="10" name="TextBox 9"/>
+          <p:cNvSpPr txBox="1"/>
+          <p:nvPr/>
+        </p:nvSpPr>
+        <p:spPr>
+          <a:xfrm>
+            <a:off x="868680" y="5596128"/>
+            <a:ext cx="10451592" cy="457200"/>
+          </a:xfrm>
+          <a:prstGeom prst="rect">
+            <a:avLst/>
+          </a:prstGeom>
+          <a:noFill/>
+        </p:spPr>
+        <p:txBody>
+          <a:bodyPr wrap="square">
+            <a:spAutoFit/>
+          </a:bodyPr>
+          <a:lstStyle/>
+          <a:p>
+            <a:pPr algn="l"/>
+            <a:r>
+              <a:rPr sz="1300" b="1" i="0">
+                <a:solidFill>
+                  <a:srgbClr val="FFFFFF"/>
                 </a:solidFill>
                 <a:latin typeface="Arial"/>
               </a:rPr>
-              <a:t>▸  ## 4.6 Typische Transferbarrieren und Gegenmaßnahmen</a:t>
-            </a:r>
-          </a:p>
-          <a:p>
-            <a:pPr marL="190500" indent="-190500">
-              <a:spcBef>
-                <a:spcPts val="400"/>
-              </a:spcBef>
-              <a:spcAft>
-                <a:spcPts val="200"/>
-              </a:spcAft>
-            </a:pPr>
-            <a:r>
-              <a:rPr sz="1300">
-                <a:solidFill>
-                  <a:srgbClr val="3D5466"/>
-                </a:solidFill>
-                <a:latin typeface="Arial"/>
-              </a:rPr>
-              <a:t>▸  ## 4.7 Praxiscase: Team Ostbayern</a:t>
-            </a:r>
-          </a:p>
-          <a:p>
-            <a:pPr marL="190500" indent="-190500">
-              <a:spcBef>
-                <a:spcPts val="400"/>
-              </a:spcBef>
-              <a:spcAft>
-                <a:spcPts val="200"/>
-              </a:spcAft>
-            </a:pPr>
-            <a:r>
-              <a:rPr sz="1300">
-                <a:solidFill>
-                  <a:srgbClr val="3D5466"/>
-                </a:solidFill>
-                <a:latin typeface="Arial"/>
-              </a:rPr>
-              <a:t>▸  Ausgangssituation</a:t>
-            </a:r>
-          </a:p>
-          <a:p>
-            <a:pPr marL="190500" indent="-190500">
-              <a:spcBef>
-                <a:spcPts val="400"/>
-              </a:spcBef>
-              <a:spcAft>
-                <a:spcPts val="200"/>
-              </a:spcAft>
-            </a:pPr>
-            <a:r>
-              <a:rPr sz="1300">
-                <a:solidFill>
-                  <a:srgbClr val="3D5466"/>
-                </a:solidFill>
-                <a:latin typeface="Arial"/>
-              </a:rPr>
-              <a:t>▸  Gleichzeitig sind drei jüngere Berater seit 2–4 Jahren im Team. Sie beherrschen agree gut, kennen aber die regionalen Besonderheiten kaum.</a:t>
-            </a:r>
-          </a:p>
-          <a:p>
-            <a:pPr marL="190500" indent="-190500">
-              <a:spcBef>
-                <a:spcPts val="400"/>
-              </a:spcBef>
-              <a:spcAft>
-                <a:spcPts val="200"/>
-              </a:spcAft>
-            </a:pPr>
-            <a:r>
-              <a:rPr sz="1300">
-                <a:solidFill>
-                  <a:srgbClr val="3D5466"/>
-                </a:solidFill>
-                <a:latin typeface="Arial"/>
-              </a:rPr>
-              <a:t>▸  Maßnahmen von Claudia Möller</a:t>
-            </a:r>
-          </a:p>
-          <a:p>
-            <a:pPr marL="190500" indent="-190500">
-              <a:spcBef>
-                <a:spcPts val="400"/>
-              </a:spcBef>
-              <a:spcAft>
-                <a:spcPts val="200"/>
-              </a:spcAft>
-            </a:pPr>
-            <a:r>
-              <a:rPr sz="1300">
-                <a:solidFill>
-                  <a:srgbClr val="3D5466"/>
-                </a:solidFill>
-                <a:latin typeface="Arial"/>
-              </a:rPr>
-              <a:t>▸  Schritt 1 – Wissenslandkarte erstellen (Monat 1):</a:t>
-            </a:r>
-          </a:p>
-          <a:p>
-            <a:pPr marL="190500" indent="-190500">
-              <a:spcBef>
-                <a:spcPts val="400"/>
-              </a:spcBef>
-              <a:spcAft>
-                <a:spcPts val="200"/>
-              </a:spcAft>
-            </a:pPr>
-            <a:r>
-              <a:rPr sz="1300">
-                <a:solidFill>
-                  <a:srgbClr val="3D5466"/>
-                </a:solidFill>
-                <a:latin typeface="Arial"/>
-              </a:rPr>
-              <a:t>▸  Schritt 2 – Tandem-Besuche einführen (Monat 2–3):</a:t>
-            </a:r>
-          </a:p>
-          <a:p>
-            <a:pPr marL="190500" indent="-190500">
-              <a:spcBef>
-                <a:spcPts val="400"/>
-              </a:spcBef>
-              <a:spcAft>
-                <a:spcPts val="200"/>
-              </a:spcAft>
-            </a:pPr>
-            <a:r>
-              <a:rPr sz="1300">
-                <a:solidFill>
-                  <a:srgbClr val="3D5466"/>
-                </a:solidFill>
-                <a:latin typeface="Arial"/>
-              </a:rPr>
-              <a:t>▸  Schritt 3 – Monatliche Fallbesprechung (ab Monat 2):</a:t>
-            </a:r>
-          </a:p>
-          <a:p>
-            <a:pPr marL="190500" indent="-190500">
-              <a:spcBef>
-                <a:spcPts val="400"/>
-              </a:spcBef>
-              <a:spcAft>
-                <a:spcPts val="200"/>
-              </a:spcAft>
-            </a:pPr>
-            <a:r>
-              <a:rPr sz="1300">
-                <a:solidFill>
-                  <a:srgbClr val="3D5466"/>
-                </a:solidFill>
-                <a:latin typeface="Arial"/>
-              </a:rPr>
-              <a:t>▸  Ergebnis nach 6 Monaten</a:t>
-            </a:r>
-          </a:p>
-        </p:txBody>
-      </p:sp>
-      <p:sp>
-        <p:nvSpPr>
-          <p:cNvPr id="9" name="Rectangle 8"/>
+              <a:t>→  Bearbeitung im Teilnehmer-Workbook (Arbeitsblatt mit Ausfüllfeldern)</a:t>
+            </a:r>
+          </a:p>
+        </p:txBody>
+      </p:sp>
+      <p:sp>
+        <p:nvSpPr>
+          <p:cNvPr id="11" name="Rectangle 10"/>
           <p:cNvSpPr/>
           <p:nvPr/>
         </p:nvSpPr>
@@ -5923,7 +5693,7 @@
       </p:sp>
       <p:sp>
         <p:nvSpPr>
-          <p:cNvPr id="10" name="TextBox 9"/>
+          <p:cNvPr id="12" name="TextBox 11"/>
           <p:cNvSpPr txBox="1"/>
           <p:nvPr/>
         </p:nvSpPr>
@@ -5989,7 +5759,7 @@
             <a:avLst/>
           </a:prstGeom>
           <a:solidFill>
-            <a:srgbClr val="FFFFFF"/>
+            <a:srgbClr val="EDEDF3"/>
           </a:solidFill>
           <a:ln>
             <a:noFill/>
@@ -6090,43 +5860,51 @@
                 </a:solidFill>
                 <a:latin typeface="Consolas"/>
               </a:rPr>
-              <a:t>M19  ·  ÜBERSICHT</a:t>
-            </a:r>
-          </a:p>
-        </p:txBody>
-      </p:sp>
-      <p:sp>
-        <p:nvSpPr>
-          <p:cNvPr id="5" name="TextBox 4"/>
-          <p:cNvSpPr txBox="1"/>
-          <p:nvPr/>
-        </p:nvSpPr>
-        <p:spPr>
-          <a:xfrm>
-            <a:off x="685800" y="502920"/>
-            <a:ext cx="10817352" cy="594360"/>
-          </a:xfrm>
-          <a:prstGeom prst="rect">
-            <a:avLst/>
-          </a:prstGeom>
-          <a:noFill/>
-        </p:spPr>
-        <p:txBody>
-          <a:bodyPr wrap="square">
-            <a:spAutoFit/>
-          </a:bodyPr>
-          <a:lstStyle/>
-          <a:p>
-            <a:pPr algn="l"/>
-            <a:r>
-              <a:rPr sz="2000" b="1" i="0">
-                <a:solidFill>
-                  <a:srgbClr val="1F2C56"/>
-                </a:solidFill>
-                <a:latin typeface="Arial"/>
-              </a:rPr>
-              <a:t>AB-1: Wissenslandkarte – eigener Steckbrief</a:t>
-            </a:r>
+              <a:t>M19  ·  INHALT</a:t>
+            </a:r>
+          </a:p>
+        </p:txBody>
+      </p:sp>
+      <p:sp>
+        <p:nvSpPr>
+          <p:cNvPr id="5" name="Rectangle 4"/>
+          <p:cNvSpPr/>
+          <p:nvPr/>
+        </p:nvSpPr>
+        <p:spPr>
+          <a:xfrm>
+            <a:off x="0" y="1234440"/>
+            <a:ext cx="12188952" cy="12700"/>
+          </a:xfrm>
+          <a:prstGeom prst="rect">
+            <a:avLst/>
+          </a:prstGeom>
+          <a:solidFill>
+            <a:srgbClr val="D8DFE4"/>
+          </a:solidFill>
+          <a:ln>
+            <a:noFill/>
+          </a:ln>
+        </p:spPr>
+        <p:style>
+          <a:lnRef idx="1">
+            <a:schemeClr val="accent1"/>
+          </a:lnRef>
+          <a:fillRef idx="3">
+            <a:schemeClr val="accent1"/>
+          </a:fillRef>
+          <a:effectRef idx="2">
+            <a:schemeClr val="accent1"/>
+          </a:effectRef>
+          <a:fontRef idx="minor">
+            <a:schemeClr val="lt1"/>
+          </a:fontRef>
+        </p:style>
+        <p:txBody>
+          <a:bodyPr rtlCol="0" anchor="ctr"/>
+          <a:lstStyle/>
+          <a:p>
+            <a:pPr algn="ctr"/>
           </a:p>
         </p:txBody>
       </p:sp>
@@ -6138,8 +5916,8 @@
         </p:nvSpPr>
         <p:spPr>
           <a:xfrm>
-            <a:off x="685800" y="1143000"/>
-            <a:ext cx="10817352" cy="25400"/>
+            <a:off x="685800" y="502920"/>
+            <a:ext cx="36576" cy="658368"/>
           </a:xfrm>
           <a:prstGeom prst="rect">
             <a:avLst/>
@@ -6173,221 +5951,105 @@
           </a:p>
         </p:txBody>
       </p:sp>
-      <p:graphicFrame>
-        <p:nvGraphicFramePr>
-          <p:cNvPr id="7" name="Table 6"/>
-          <p:cNvGraphicFramePr>
-            <a:graphicFrameLocks noGrp="1"/>
-          </p:cNvGraphicFramePr>
-          <p:nvPr/>
-        </p:nvGraphicFramePr>
-        <p:xfrm>
-          <a:off x="685800" y="1417320"/>
-          <a:ext cx="10817352" cy="2304288"/>
-        </p:xfrm>
-        <a:graphic>
-          <a:graphicData uri="http://schemas.openxmlformats.org/drawingml/2006/table">
-            <a:tbl>
-              <a:tblPr firstRow="1" bandRow="1">
-                <a:tableStyleId>{5C22544A-7EE6-4342-B048-85BDC9FD1C3A}</a:tableStyleId>
-              </a:tblPr>
-              <a:tblGrid>
-                <a:gridCol w="5408676"/>
-                <a:gridCol w="5408676"/>
-              </a:tblGrid>
-              <a:tr h="384048">
-                <a:tc>
-                  <a:txBody>
-                    <a:bodyPr/>
-                    <a:lstStyle/>
-                    <a:p>
-                      <a:r>
-                        <a:rPr sz="1100" b="1">
-                          <a:solidFill>
-                            <a:srgbClr val="FFFFFF"/>
-                          </a:solidFill>
-                          <a:latin typeface="Arial"/>
-                        </a:rPr>
-                        <a:t>Frage</a:t>
-                      </a:r>
-                    </a:p>
-                  </a:txBody>
-                  <a:tcPr>
-                    <a:solidFill>
-                      <a:srgbClr val="1F2C56"/>
-                    </a:solidFill>
-                  </a:tcPr>
-                </a:tc>
-                <a:tc>
-                  <a:txBody>
-                    <a:bodyPr/>
-                    <a:lstStyle/>
-                    <a:p>
-                      <a:r>
-                        <a:rPr sz="1100" b="1">
-                          <a:solidFill>
-                            <a:srgbClr val="FFFFFF"/>
-                          </a:solidFill>
-                          <a:latin typeface="Arial"/>
-                        </a:rPr>
-                        <a:t>Ihre Antwort</a:t>
-                      </a:r>
-                    </a:p>
-                  </a:txBody>
-                  <a:tcPr>
-                    <a:solidFill>
-                      <a:srgbClr val="1F2C56"/>
-                    </a:solidFill>
-                  </a:tcPr>
-                </a:tc>
-              </a:tr>
-              <a:tr h="384048">
-                <a:tc>
-                  <a:txBody>
-                    <a:bodyPr/>
-                    <a:lstStyle/>
-                    <a:p>
-                      <a:r>
-                        <a:rPr sz="1050">
-                          <a:solidFill>
-                            <a:srgbClr val="3D5466"/>
-                          </a:solidFill>
-                          <a:latin typeface="Arial"/>
-                        </a:rPr>
-                        <a:t>Meine Branchenschwerpunkte (Top 3)</a:t>
-                      </a:r>
-                    </a:p>
-                  </a:txBody>
-                  <a:tcPr/>
-                </a:tc>
-                <a:tc>
-                  <a:txBody>
-                    <a:bodyPr/>
-                    <a:lstStyle/>
-                    <a:p/>
-                  </a:txBody>
-                  <a:tcPr/>
-                </a:tc>
-              </a:tr>
-              <a:tr h="384048">
-                <a:tc>
-                  <a:txBody>
-                    <a:bodyPr/>
-                    <a:lstStyle/>
-                    <a:p>
-                      <a:r>
-                        <a:rPr sz="1050">
-                          <a:solidFill>
-                            <a:srgbClr val="3D5466"/>
-                          </a:solidFill>
-                          <a:latin typeface="Arial"/>
-                        </a:rPr>
-                        <a:t>Wissen, das ich habe und andere kaum (implizit)</a:t>
-                      </a:r>
-                    </a:p>
-                  </a:txBody>
-                  <a:tcPr/>
-                </a:tc>
-                <a:tc>
-                  <a:txBody>
-                    <a:bodyPr/>
-                    <a:lstStyle/>
-                    <a:p/>
-                  </a:txBody>
-                  <a:tcPr/>
-                </a:tc>
-              </a:tr>
-              <a:tr h="384048">
-                <a:tc>
-                  <a:txBody>
-                    <a:bodyPr/>
-                    <a:lstStyle/>
-                    <a:p>
-                      <a:r>
-                        <a:rPr sz="1050">
-                          <a:solidFill>
-                            <a:srgbClr val="3D5466"/>
-                          </a:solidFill>
-                          <a:latin typeface="Arial"/>
-                        </a:rPr>
-                        <a:t>Erfahrungen, die ich gerne weitergeben würde</a:t>
-                      </a:r>
-                    </a:p>
-                  </a:txBody>
-                  <a:tcPr/>
-                </a:tc>
-                <a:tc>
-                  <a:txBody>
-                    <a:bodyPr/>
-                    <a:lstStyle/>
-                    <a:p/>
-                  </a:txBody>
-                  <a:tcPr/>
-                </a:tc>
-              </a:tr>
-              <a:tr h="384048">
-                <a:tc>
-                  <a:txBody>
-                    <a:bodyPr/>
-                    <a:lstStyle/>
-                    <a:p>
-                      <a:r>
-                        <a:rPr sz="1050">
-                          <a:solidFill>
-                            <a:srgbClr val="3D5466"/>
-                          </a:solidFill>
-                          <a:latin typeface="Arial"/>
-                        </a:rPr>
-                        <a:t>Themen, bei denen ich von anderen lernen möchte</a:t>
-                      </a:r>
-                    </a:p>
-                  </a:txBody>
-                  <a:tcPr/>
-                </a:tc>
-                <a:tc>
-                  <a:txBody>
-                    <a:bodyPr/>
-                    <a:lstStyle/>
-                    <a:p/>
-                  </a:txBody>
-                  <a:tcPr/>
-                </a:tc>
-              </a:tr>
-              <a:tr h="384048">
-                <a:tc>
-                  <a:txBody>
-                    <a:bodyPr/>
-                    <a:lstStyle/>
-                    <a:p>
-                      <a:r>
-                        <a:rPr sz="1050">
-                          <a:solidFill>
-                            <a:srgbClr val="3D5466"/>
-                          </a:solidFill>
-                          <a:latin typeface="Arial"/>
-                        </a:rPr>
-                        <a:t>Kollegen, die ich gerne als Tandem-Partner hätte</a:t>
-                      </a:r>
-                    </a:p>
-                  </a:txBody>
-                  <a:tcPr/>
-                </a:tc>
-                <a:tc>
-                  <a:txBody>
-                    <a:bodyPr/>
-                    <a:lstStyle/>
-                    <a:p/>
-                  </a:txBody>
-                  <a:tcPr/>
-                </a:tc>
-              </a:tr>
-            </a:tbl>
-          </a:graphicData>
-        </a:graphic>
-      </p:graphicFrame>
-      <p:sp>
-        <p:nvSpPr>
-          <p:cNvPr id="8" name="Rectangle 7"/>
+      <p:sp>
+        <p:nvSpPr>
+          <p:cNvPr id="7" name="TextBox 6"/>
+          <p:cNvSpPr txBox="1"/>
+          <p:nvPr/>
+        </p:nvSpPr>
+        <p:spPr>
+          <a:xfrm>
+            <a:off x="813816" y="502920"/>
+            <a:ext cx="10634472" cy="685800"/>
+          </a:xfrm>
+          <a:prstGeom prst="rect">
+            <a:avLst/>
+          </a:prstGeom>
+          <a:noFill/>
+        </p:spPr>
+        <p:txBody>
+          <a:bodyPr wrap="square">
+            <a:spAutoFit/>
+          </a:bodyPr>
+          <a:lstStyle/>
+          <a:p>
+            <a:pPr algn="l"/>
+            <a:r>
+              <a:rPr sz="2400" b="1" i="0">
+                <a:solidFill>
+                  <a:srgbClr val="1F2C56"/>
+                </a:solidFill>
+                <a:latin typeface="Arial"/>
+              </a:rPr>
+              <a:t>Prinzip dieses Moduls</a:t>
+            </a:r>
+          </a:p>
+        </p:txBody>
+      </p:sp>
+      <p:sp>
+        <p:nvSpPr>
+          <p:cNvPr id="8" name="TextBox 7"/>
+          <p:cNvSpPr txBox="1"/>
+          <p:nvPr/>
+        </p:nvSpPr>
+        <p:spPr>
+          <a:xfrm>
+            <a:off x="685800" y="1417320"/>
+            <a:ext cx="10817352" cy="4892040"/>
+          </a:xfrm>
+          <a:prstGeom prst="rect">
+            <a:avLst/>
+          </a:prstGeom>
+          <a:noFill/>
+        </p:spPr>
+        <p:txBody>
+          <a:bodyPr wrap="square" anchor="ctr">
+            <a:spAutoFit/>
+          </a:bodyPr>
+          <a:lstStyle/>
+          <a:p>
+            <a:pPr marL="177800" indent="-177800">
+              <a:spcBef>
+                <a:spcPts val="600"/>
+              </a:spcBef>
+              <a:spcAft>
+                <a:spcPts val="200"/>
+              </a:spcAft>
+            </a:pPr>
+            <a:r>
+              <a:rPr sz="1200" i="1">
+                <a:solidFill>
+                  <a:srgbClr val="3D5466"/>
+                </a:solidFill>
+                <a:latin typeface="Arial"/>
+              </a:rPr>
+              <a:t>→  Wissen, das nur in einem Kopf liegt, ist ein Risiko – kein Vorsprung.</a:t>
+            </a:r>
+          </a:p>
+          <a:p>
+            <a:pPr marL="190500" indent="-190500">
+              <a:spcBef>
+                <a:spcPts val="400"/>
+              </a:spcBef>
+              <a:spcAft>
+                <a:spcPts val="200"/>
+              </a:spcAft>
+            </a:pPr>
+            <a:r>
+              <a:rPr sz="1300">
+                <a:solidFill>
+                  <a:srgbClr val="3D5466"/>
+                </a:solidFill>
+                <a:latin typeface="Arial"/>
+              </a:rPr>
+              <a:t>▸  Erst geteiltes Wissen macht das Team stärker als die Summe seiner Berater; Transfer ist Führungsaufgabe.</a:t>
+            </a:r>
+          </a:p>
+        </p:txBody>
+      </p:sp>
+      <p:sp>
+        <p:nvSpPr>
+          <p:cNvPr id="9" name="Rectangle 8"/>
           <p:cNvSpPr/>
           <p:nvPr/>
         </p:nvSpPr>
@@ -6430,7 +6092,7 @@
       </p:sp>
       <p:sp>
         <p:nvSpPr>
-          <p:cNvPr id="9" name="TextBox 8"/>
+          <p:cNvPr id="10" name="TextBox 9"/>
           <p:cNvSpPr txBox="1"/>
           <p:nvPr/>
         </p:nvSpPr>
@@ -6459,41 +6121,6 @@
                 <a:latin typeface="Consolas"/>
               </a:rPr>
               <a:t>FKB Campus  ·  M19</a:t>
-            </a:r>
-          </a:p>
-        </p:txBody>
-      </p:sp>
-      <p:sp>
-        <p:nvSpPr>
-          <p:cNvPr id="10" name="TextBox 9"/>
-          <p:cNvSpPr txBox="1"/>
-          <p:nvPr/>
-        </p:nvSpPr>
-        <p:spPr>
-          <a:xfrm>
-            <a:off x="7176211" y="6583680"/>
-            <a:ext cx="4326940" cy="256032"/>
-          </a:xfrm>
-          <a:prstGeom prst="rect">
-            <a:avLst/>
-          </a:prstGeom>
-          <a:noFill/>
-        </p:spPr>
-        <p:txBody>
-          <a:bodyPr wrap="none">
-            <a:spAutoFit/>
-          </a:bodyPr>
-          <a:lstStyle/>
-          <a:p>
-            <a:pPr algn="r"/>
-            <a:r>
-              <a:rPr sz="700">
-                <a:solidFill>
-                  <a:srgbClr val="A0B4D2"/>
-                </a:solidFill>
-                <a:latin typeface="Consolas"/>
-              </a:rPr>
-              <a:t>Übersicht</a:t>
             </a:r>
           </a:p>
         </p:txBody>
@@ -6753,7 +6380,7 @@
                 </a:solidFill>
                 <a:latin typeface="Arial"/>
               </a:rPr>
-              <a:t>AB-2: Fallbesprechung vorbereiten</a:t>
+              <a:t>Reflexion und Selbstcheck</a:t>
             </a:r>
           </a:p>
         </p:txBody>
@@ -6795,7 +6422,45 @@
                 </a:solidFill>
                 <a:latin typeface="Arial"/>
               </a:rPr>
-              <a:t>▸  (für den Fallbringer)</a:t>
+              <a:t>▸  Welches Wissen in Ihrem Team liegt riskant in nur einem Kopf?</a:t>
+            </a:r>
+          </a:p>
+          <a:p>
+            <a:pPr marL="190500" indent="-190500">
+              <a:spcBef>
+                <a:spcPts val="400"/>
+              </a:spcBef>
+              <a:spcAft>
+                <a:spcPts val="200"/>
+              </a:spcAft>
+            </a:pPr>
+            <a:r>
+              <a:rPr sz="1300">
+                <a:solidFill>
+                  <a:srgbClr val="3D5466"/>
+                </a:solidFill>
+                <a:latin typeface="Arial"/>
+              </a:rPr>
+              <a:t>▸  Welche der fünf Methoden würde in Ihrem Team am ehesten funktionieren?</a:t>
+            </a:r>
+          </a:p>
+          <a:p>
+            <a:pPr marL="190500" indent="-190500">
+              <a:spcBef>
+                <a:spcPts val="400"/>
+              </a:spcBef>
+              <a:spcAft>
+                <a:spcPts val="200"/>
+              </a:spcAft>
+            </a:pPr>
+            <a:r>
+              <a:rPr sz="1300">
+                <a:solidFill>
+                  <a:srgbClr val="3D5466"/>
+                </a:solidFill>
+                <a:latin typeface="Arial"/>
+              </a:rPr>
+              <a:t>▸  Welche eine Transfer-Routine führen Sie im nächsten Monat verbindlich ein?</a:t>
             </a:r>
           </a:p>
         </p:txBody>
@@ -6874,737 +6539,6 @@
                 <a:latin typeface="Consolas"/>
               </a:rPr>
               <a:t>FKB Campus  ·  M19</a:t>
-            </a:r>
-          </a:p>
-        </p:txBody>
-      </p:sp>
-    </p:spTree>
-  </p:cSld>
-  <p:clrMapOvr>
-    <a:masterClrMapping/>
-  </p:clrMapOvr>
-</p:sld>
-</file>
-
-<file path=ppt/slides/slide15.xml><?xml version="1.0" encoding="utf-8"?>
-<p:sld xmlns:a="http://schemas.openxmlformats.org/drawingml/2006/main" xmlns:p="http://schemas.openxmlformats.org/presentationml/2006/main" xmlns:r="http://schemas.openxmlformats.org/officeDocument/2006/relationships">
-  <p:cSld>
-    <p:spTree>
-      <p:nvGrpSpPr>
-        <p:cNvPr id="1" name=""/>
-        <p:cNvGrpSpPr/>
-        <p:nvPr/>
-      </p:nvGrpSpPr>
-      <p:grpSpPr/>
-      <p:sp>
-        <p:nvSpPr>
-          <p:cNvPr id="2" name="Rectangle 1"/>
-          <p:cNvSpPr/>
-          <p:nvPr/>
-        </p:nvSpPr>
-        <p:spPr>
-          <a:xfrm>
-            <a:off x="0" y="0"/>
-            <a:ext cx="12188952" cy="6858000"/>
-          </a:xfrm>
-          <a:prstGeom prst="rect">
-            <a:avLst/>
-          </a:prstGeom>
-          <a:solidFill>
-            <a:srgbClr val="FFFFFF"/>
-          </a:solidFill>
-          <a:ln>
-            <a:noFill/>
-          </a:ln>
-        </p:spPr>
-        <p:style>
-          <a:lnRef idx="1">
-            <a:schemeClr val="accent1"/>
-          </a:lnRef>
-          <a:fillRef idx="3">
-            <a:schemeClr val="accent1"/>
-          </a:fillRef>
-          <a:effectRef idx="2">
-            <a:schemeClr val="accent1"/>
-          </a:effectRef>
-          <a:fontRef idx="minor">
-            <a:schemeClr val="lt1"/>
-          </a:fontRef>
-        </p:style>
-        <p:txBody>
-          <a:bodyPr rtlCol="0" anchor="ctr"/>
-          <a:lstStyle/>
-          <a:p>
-            <a:pPr algn="ctr"/>
-          </a:p>
-        </p:txBody>
-      </p:sp>
-      <p:sp>
-        <p:nvSpPr>
-          <p:cNvPr id="3" name="Rectangle 2"/>
-          <p:cNvSpPr/>
-          <p:nvPr/>
-        </p:nvSpPr>
-        <p:spPr>
-          <a:xfrm>
-            <a:off x="0" y="0"/>
-            <a:ext cx="12188952" cy="50292"/>
-          </a:xfrm>
-          <a:prstGeom prst="rect">
-            <a:avLst/>
-          </a:prstGeom>
-          <a:solidFill>
-            <a:srgbClr val="1F2C56"/>
-          </a:solidFill>
-          <a:ln>
-            <a:noFill/>
-          </a:ln>
-        </p:spPr>
-        <p:style>
-          <a:lnRef idx="1">
-            <a:schemeClr val="accent1"/>
-          </a:lnRef>
-          <a:fillRef idx="3">
-            <a:schemeClr val="accent1"/>
-          </a:fillRef>
-          <a:effectRef idx="2">
-            <a:schemeClr val="accent1"/>
-          </a:effectRef>
-          <a:fontRef idx="minor">
-            <a:schemeClr val="lt1"/>
-          </a:fontRef>
-        </p:style>
-        <p:txBody>
-          <a:bodyPr rtlCol="0" anchor="ctr"/>
-          <a:lstStyle/>
-          <a:p>
-            <a:pPr algn="ctr"/>
-          </a:p>
-        </p:txBody>
-      </p:sp>
-      <p:sp>
-        <p:nvSpPr>
-          <p:cNvPr id="4" name="TextBox 3"/>
-          <p:cNvSpPr txBox="1"/>
-          <p:nvPr/>
-        </p:nvSpPr>
-        <p:spPr>
-          <a:xfrm>
-            <a:off x="685800" y="109728"/>
-            <a:ext cx="10817352" cy="228600"/>
-          </a:xfrm>
-          <a:prstGeom prst="rect">
-            <a:avLst/>
-          </a:prstGeom>
-          <a:noFill/>
-        </p:spPr>
-        <p:txBody>
-          <a:bodyPr wrap="none">
-            <a:spAutoFit/>
-          </a:bodyPr>
-          <a:lstStyle/>
-          <a:p>
-            <a:pPr algn="l"/>
-            <a:r>
-              <a:rPr sz="750">
-                <a:solidFill>
-                  <a:srgbClr val="78808C"/>
-                </a:solidFill>
-                <a:latin typeface="Consolas"/>
-              </a:rPr>
-              <a:t>M19  ·  ÜBERSICHT</a:t>
-            </a:r>
-          </a:p>
-        </p:txBody>
-      </p:sp>
-      <p:sp>
-        <p:nvSpPr>
-          <p:cNvPr id="5" name="TextBox 4"/>
-          <p:cNvSpPr txBox="1"/>
-          <p:nvPr/>
-        </p:nvSpPr>
-        <p:spPr>
-          <a:xfrm>
-            <a:off x="685800" y="502920"/>
-            <a:ext cx="10817352" cy="594360"/>
-          </a:xfrm>
-          <a:prstGeom prst="rect">
-            <a:avLst/>
-          </a:prstGeom>
-          <a:noFill/>
-        </p:spPr>
-        <p:txBody>
-          <a:bodyPr wrap="square">
-            <a:spAutoFit/>
-          </a:bodyPr>
-          <a:lstStyle/>
-          <a:p>
-            <a:pPr algn="l"/>
-            <a:r>
-              <a:rPr sz="2000" b="1" i="0">
-                <a:solidFill>
-                  <a:srgbClr val="1F2C56"/>
-                </a:solidFill>
-                <a:latin typeface="Arial"/>
-              </a:rPr>
-              <a:t>AB-3: Wissenstransfer-Maßnahmenplan</a:t>
-            </a:r>
-          </a:p>
-        </p:txBody>
-      </p:sp>
-      <p:sp>
-        <p:nvSpPr>
-          <p:cNvPr id="6" name="Rectangle 5"/>
-          <p:cNvSpPr/>
-          <p:nvPr/>
-        </p:nvSpPr>
-        <p:spPr>
-          <a:xfrm>
-            <a:off x="685800" y="1143000"/>
-            <a:ext cx="10817352" cy="25400"/>
-          </a:xfrm>
-          <a:prstGeom prst="rect">
-            <a:avLst/>
-          </a:prstGeom>
-          <a:solidFill>
-            <a:srgbClr val="D9C089"/>
-          </a:solidFill>
-          <a:ln>
-            <a:noFill/>
-          </a:ln>
-        </p:spPr>
-        <p:style>
-          <a:lnRef idx="1">
-            <a:schemeClr val="accent1"/>
-          </a:lnRef>
-          <a:fillRef idx="3">
-            <a:schemeClr val="accent1"/>
-          </a:fillRef>
-          <a:effectRef idx="2">
-            <a:schemeClr val="accent1"/>
-          </a:effectRef>
-          <a:fontRef idx="minor">
-            <a:schemeClr val="lt1"/>
-          </a:fontRef>
-        </p:style>
-        <p:txBody>
-          <a:bodyPr rtlCol="0" anchor="ctr"/>
-          <a:lstStyle/>
-          <a:p>
-            <a:pPr algn="ctr"/>
-          </a:p>
-        </p:txBody>
-      </p:sp>
-      <p:graphicFrame>
-        <p:nvGraphicFramePr>
-          <p:cNvPr id="7" name="Table 6"/>
-          <p:cNvGraphicFramePr>
-            <a:graphicFrameLocks noGrp="1"/>
-          </p:cNvGraphicFramePr>
-          <p:nvPr/>
-        </p:nvGraphicFramePr>
-        <p:xfrm>
-          <a:off x="685800" y="1417320"/>
-          <a:ext cx="10817352" cy="2304288"/>
-        </p:xfrm>
-        <a:graphic>
-          <a:graphicData uri="http://schemas.openxmlformats.org/drawingml/2006/table">
-            <a:tbl>
-              <a:tblPr firstRow="1" bandRow="1">
-                <a:tableStyleId>{5C22544A-7EE6-4342-B048-85BDC9FD1C3A}</a:tableStyleId>
-              </a:tblPr>
-              <a:tblGrid>
-                <a:gridCol w="2163470"/>
-                <a:gridCol w="2163470"/>
-                <a:gridCol w="2163470"/>
-                <a:gridCol w="2163470"/>
-                <a:gridCol w="2163472"/>
-              </a:tblGrid>
-              <a:tr h="384048">
-                <a:tc>
-                  <a:txBody>
-                    <a:bodyPr/>
-                    <a:lstStyle/>
-                    <a:p>
-                      <a:r>
-                        <a:rPr sz="1100" b="1">
-                          <a:solidFill>
-                            <a:srgbClr val="FFFFFF"/>
-                          </a:solidFill>
-                          <a:latin typeface="Arial"/>
-                        </a:rPr>
-                        <a:t>Methode</a:t>
-                      </a:r>
-                    </a:p>
-                  </a:txBody>
-                  <a:tcPr>
-                    <a:solidFill>
-                      <a:srgbClr val="1F2C56"/>
-                    </a:solidFill>
-                  </a:tcPr>
-                </a:tc>
-                <a:tc>
-                  <a:txBody>
-                    <a:bodyPr/>
-                    <a:lstStyle/>
-                    <a:p>
-                      <a:r>
-                        <a:rPr sz="1100" b="1">
-                          <a:solidFill>
-                            <a:srgbClr val="FFFFFF"/>
-                          </a:solidFill>
-                          <a:latin typeface="Arial"/>
-                        </a:rPr>
-                        <a:t>Wann?</a:t>
-                      </a:r>
-                    </a:p>
-                  </a:txBody>
-                  <a:tcPr>
-                    <a:solidFill>
-                      <a:srgbClr val="1F2C56"/>
-                    </a:solidFill>
-                  </a:tcPr>
-                </a:tc>
-                <a:tc>
-                  <a:txBody>
-                    <a:bodyPr/>
-                    <a:lstStyle/>
-                    <a:p>
-                      <a:r>
-                        <a:rPr sz="1100" b="1">
-                          <a:solidFill>
-                            <a:srgbClr val="FFFFFF"/>
-                          </a:solidFill>
-                          <a:latin typeface="Arial"/>
-                        </a:rPr>
-                        <a:t>Wer organisiert?</a:t>
-                      </a:r>
-                    </a:p>
-                  </a:txBody>
-                  <a:tcPr>
-                    <a:solidFill>
-                      <a:srgbClr val="1F2C56"/>
-                    </a:solidFill>
-                  </a:tcPr>
-                </a:tc>
-                <a:tc>
-                  <a:txBody>
-                    <a:bodyPr/>
-                    <a:lstStyle/>
-                    <a:p>
-                      <a:r>
-                        <a:rPr sz="1100" b="1">
-                          <a:solidFill>
-                            <a:srgbClr val="FFFFFF"/>
-                          </a:solidFill>
-                          <a:latin typeface="Arial"/>
-                        </a:rPr>
-                        <a:t>Wer nimmt teil?</a:t>
-                      </a:r>
-                    </a:p>
-                  </a:txBody>
-                  <a:tcPr>
-                    <a:solidFill>
-                      <a:srgbClr val="1F2C56"/>
-                    </a:solidFill>
-                  </a:tcPr>
-                </a:tc>
-                <a:tc>
-                  <a:txBody>
-                    <a:bodyPr/>
-                    <a:lstStyle/>
-                    <a:p>
-                      <a:r>
-                        <a:rPr sz="1100" b="1">
-                          <a:solidFill>
-                            <a:srgbClr val="FFFFFF"/>
-                          </a:solidFill>
-                          <a:latin typeface="Arial"/>
-                        </a:rPr>
-                        <a:t>Erfolgskriterium</a:t>
-                      </a:r>
-                    </a:p>
-                  </a:txBody>
-                  <a:tcPr>
-                    <a:solidFill>
-                      <a:srgbClr val="1F2C56"/>
-                    </a:solidFill>
-                  </a:tcPr>
-                </a:tc>
-              </a:tr>
-              <a:tr h="384048">
-                <a:tc>
-                  <a:txBody>
-                    <a:bodyPr/>
-                    <a:lstStyle/>
-                    <a:p>
-                      <a:r>
-                        <a:rPr sz="1050">
-                          <a:solidFill>
-                            <a:srgbClr val="3D5466"/>
-                          </a:solidFill>
-                          <a:latin typeface="Arial"/>
-                        </a:rPr>
-                        <a:t>Tandem-Besuche</a:t>
-                      </a:r>
-                    </a:p>
-                  </a:txBody>
-                  <a:tcPr/>
-                </a:tc>
-                <a:tc>
-                  <a:txBody>
-                    <a:bodyPr/>
-                    <a:lstStyle/>
-                    <a:p/>
-                  </a:txBody>
-                  <a:tcPr/>
-                </a:tc>
-                <a:tc>
-                  <a:txBody>
-                    <a:bodyPr/>
-                    <a:lstStyle/>
-                    <a:p/>
-                  </a:txBody>
-                  <a:tcPr/>
-                </a:tc>
-                <a:tc>
-                  <a:txBody>
-                    <a:bodyPr/>
-                    <a:lstStyle/>
-                    <a:p/>
-                  </a:txBody>
-                  <a:tcPr/>
-                </a:tc>
-                <a:tc>
-                  <a:txBody>
-                    <a:bodyPr/>
-                    <a:lstStyle/>
-                    <a:p/>
-                  </a:txBody>
-                  <a:tcPr/>
-                </a:tc>
-              </a:tr>
-              <a:tr h="384048">
-                <a:tc>
-                  <a:txBody>
-                    <a:bodyPr/>
-                    <a:lstStyle/>
-                    <a:p>
-                      <a:r>
-                        <a:rPr sz="1050">
-                          <a:solidFill>
-                            <a:srgbClr val="3D5466"/>
-                          </a:solidFill>
-                          <a:latin typeface="Arial"/>
-                        </a:rPr>
-                        <a:t>Monatliche Fallbesprechung</a:t>
-                      </a:r>
-                    </a:p>
-                  </a:txBody>
-                  <a:tcPr/>
-                </a:tc>
-                <a:tc>
-                  <a:txBody>
-                    <a:bodyPr/>
-                    <a:lstStyle/>
-                    <a:p/>
-                  </a:txBody>
-                  <a:tcPr/>
-                </a:tc>
-                <a:tc>
-                  <a:txBody>
-                    <a:bodyPr/>
-                    <a:lstStyle/>
-                    <a:p/>
-                  </a:txBody>
-                  <a:tcPr/>
-                </a:tc>
-                <a:tc>
-                  <a:txBody>
-                    <a:bodyPr/>
-                    <a:lstStyle/>
-                    <a:p/>
-                  </a:txBody>
-                  <a:tcPr/>
-                </a:tc>
-                <a:tc>
-                  <a:txBody>
-                    <a:bodyPr/>
-                    <a:lstStyle/>
-                    <a:p/>
-                  </a:txBody>
-                  <a:tcPr/>
-                </a:tc>
-              </a:tr>
-              <a:tr h="384048">
-                <a:tc>
-                  <a:txBody>
-                    <a:bodyPr/>
-                    <a:lstStyle/>
-                    <a:p>
-                      <a:r>
-                        <a:rPr sz="1050">
-                          <a:solidFill>
-                            <a:srgbClr val="3D5466"/>
-                          </a:solidFill>
-                          <a:latin typeface="Arial"/>
-                        </a:rPr>
-                        <a:t>Wissenslandkarte</a:t>
-                      </a:r>
-                    </a:p>
-                  </a:txBody>
-                  <a:tcPr/>
-                </a:tc>
-                <a:tc>
-                  <a:txBody>
-                    <a:bodyPr/>
-                    <a:lstStyle/>
-                    <a:p/>
-                  </a:txBody>
-                  <a:tcPr/>
-                </a:tc>
-                <a:tc>
-                  <a:txBody>
-                    <a:bodyPr/>
-                    <a:lstStyle/>
-                    <a:p/>
-                  </a:txBody>
-                  <a:tcPr/>
-                </a:tc>
-                <a:tc>
-                  <a:txBody>
-                    <a:bodyPr/>
-                    <a:lstStyle/>
-                    <a:p/>
-                  </a:txBody>
-                  <a:tcPr/>
-                </a:tc>
-                <a:tc>
-                  <a:txBody>
-                    <a:bodyPr/>
-                    <a:lstStyle/>
-                    <a:p/>
-                  </a:txBody>
-                  <a:tcPr/>
-                </a:tc>
-              </a:tr>
-              <a:tr h="384048">
-                <a:tc>
-                  <a:txBody>
-                    <a:bodyPr/>
-                    <a:lstStyle/>
-                    <a:p>
-                      <a:r>
-                        <a:rPr sz="1050">
-                          <a:solidFill>
-                            <a:srgbClr val="3D5466"/>
-                          </a:solidFill>
-                          <a:latin typeface="Arial"/>
-                        </a:rPr>
-                        <a:t>Lunch-and-Learn</a:t>
-                      </a:r>
-                    </a:p>
-                  </a:txBody>
-                  <a:tcPr/>
-                </a:tc>
-                <a:tc>
-                  <a:txBody>
-                    <a:bodyPr/>
-                    <a:lstStyle/>
-                    <a:p/>
-                  </a:txBody>
-                  <a:tcPr/>
-                </a:tc>
-                <a:tc>
-                  <a:txBody>
-                    <a:bodyPr/>
-                    <a:lstStyle/>
-                    <a:p/>
-                  </a:txBody>
-                  <a:tcPr/>
-                </a:tc>
-                <a:tc>
-                  <a:txBody>
-                    <a:bodyPr/>
-                    <a:lstStyle/>
-                    <a:p/>
-                  </a:txBody>
-                  <a:tcPr/>
-                </a:tc>
-                <a:tc>
-                  <a:txBody>
-                    <a:bodyPr/>
-                    <a:lstStyle/>
-                    <a:p/>
-                  </a:txBody>
-                  <a:tcPr/>
-                </a:tc>
-              </a:tr>
-              <a:tr h="384048">
-                <a:tc>
-                  <a:txBody>
-                    <a:bodyPr/>
-                    <a:lstStyle/>
-                    <a:p>
-                      <a:r>
-                        <a:rPr sz="1050">
-                          <a:solidFill>
-                            <a:srgbClr val="3D5466"/>
-                          </a:solidFill>
-                          <a:latin typeface="Arial"/>
-                        </a:rPr>
-                        <a:t>Reverse Mentoring</a:t>
-                      </a:r>
-                    </a:p>
-                  </a:txBody>
-                  <a:tcPr/>
-                </a:tc>
-                <a:tc>
-                  <a:txBody>
-                    <a:bodyPr/>
-                    <a:lstStyle/>
-                    <a:p/>
-                  </a:txBody>
-                  <a:tcPr/>
-                </a:tc>
-                <a:tc>
-                  <a:txBody>
-                    <a:bodyPr/>
-                    <a:lstStyle/>
-                    <a:p/>
-                  </a:txBody>
-                  <a:tcPr/>
-                </a:tc>
-                <a:tc>
-                  <a:txBody>
-                    <a:bodyPr/>
-                    <a:lstStyle/>
-                    <a:p/>
-                  </a:txBody>
-                  <a:tcPr/>
-                </a:tc>
-                <a:tc>
-                  <a:txBody>
-                    <a:bodyPr/>
-                    <a:lstStyle/>
-                    <a:p/>
-                  </a:txBody>
-                  <a:tcPr/>
-                </a:tc>
-              </a:tr>
-            </a:tbl>
-          </a:graphicData>
-        </a:graphic>
-      </p:graphicFrame>
-      <p:sp>
-        <p:nvSpPr>
-          <p:cNvPr id="8" name="Rectangle 7"/>
-          <p:cNvSpPr/>
-          <p:nvPr/>
-        </p:nvSpPr>
-        <p:spPr>
-          <a:xfrm>
-            <a:off x="0" y="6510528"/>
-            <a:ext cx="12188952" cy="347472"/>
-          </a:xfrm>
-          <a:prstGeom prst="rect">
-            <a:avLst/>
-          </a:prstGeom>
-          <a:solidFill>
-            <a:srgbClr val="0A1937"/>
-          </a:solidFill>
-          <a:ln>
-            <a:noFill/>
-          </a:ln>
-        </p:spPr>
-        <p:style>
-          <a:lnRef idx="1">
-            <a:schemeClr val="accent1"/>
-          </a:lnRef>
-          <a:fillRef idx="3">
-            <a:schemeClr val="accent1"/>
-          </a:fillRef>
-          <a:effectRef idx="2">
-            <a:schemeClr val="accent1"/>
-          </a:effectRef>
-          <a:fontRef idx="minor">
-            <a:schemeClr val="lt1"/>
-          </a:fontRef>
-        </p:style>
-        <p:txBody>
-          <a:bodyPr rtlCol="0" anchor="ctr"/>
-          <a:lstStyle/>
-          <a:p>
-            <a:pPr algn="ctr"/>
-          </a:p>
-        </p:txBody>
-      </p:sp>
-      <p:sp>
-        <p:nvSpPr>
-          <p:cNvPr id="9" name="TextBox 8"/>
-          <p:cNvSpPr txBox="1"/>
-          <p:nvPr/>
-        </p:nvSpPr>
-        <p:spPr>
-          <a:xfrm>
-            <a:off x="685800" y="6583680"/>
-            <a:ext cx="6490411" cy="256032"/>
-          </a:xfrm>
-          <a:prstGeom prst="rect">
-            <a:avLst/>
-          </a:prstGeom>
-          <a:noFill/>
-        </p:spPr>
-        <p:txBody>
-          <a:bodyPr wrap="none">
-            <a:spAutoFit/>
-          </a:bodyPr>
-          <a:lstStyle/>
-          <a:p>
-            <a:pPr algn="l"/>
-            <a:r>
-              <a:rPr sz="700">
-                <a:solidFill>
-                  <a:srgbClr val="A0B4D2"/>
-                </a:solidFill>
-                <a:latin typeface="Consolas"/>
-              </a:rPr>
-              <a:t>FKB Campus  ·  M19</a:t>
-            </a:r>
-          </a:p>
-        </p:txBody>
-      </p:sp>
-      <p:sp>
-        <p:nvSpPr>
-          <p:cNvPr id="10" name="TextBox 9"/>
-          <p:cNvSpPr txBox="1"/>
-          <p:nvPr/>
-        </p:nvSpPr>
-        <p:spPr>
-          <a:xfrm>
-            <a:off x="7176211" y="6583680"/>
-            <a:ext cx="4326940" cy="256032"/>
-          </a:xfrm>
-          <a:prstGeom prst="rect">
-            <a:avLst/>
-          </a:prstGeom>
-          <a:noFill/>
-        </p:spPr>
-        <p:txBody>
-          <a:bodyPr wrap="none">
-            <a:spAutoFit/>
-          </a:bodyPr>
-          <a:lstStyle/>
-          <a:p>
-            <a:pPr algn="r"/>
-            <a:r>
-              <a:rPr sz="700">
-                <a:solidFill>
-                  <a:srgbClr val="A0B4D2"/>
-                </a:solidFill>
-                <a:latin typeface="Consolas"/>
-              </a:rPr>
-              <a:t>Übersicht</a:t>
             </a:r>
           </a:p>
         </p:txBody>
@@ -9100,7 +8034,7 @@
             <a:avLst/>
           </a:prstGeom>
           <a:solidFill>
-            <a:srgbClr val="FFFFFF"/>
+            <a:srgbClr val="EDEDF3"/>
           </a:solidFill>
           <a:ln>
             <a:noFill/>
@@ -9201,43 +8135,51 @@
                 </a:solidFill>
                 <a:latin typeface="Consolas"/>
               </a:rPr>
-              <a:t>M19  ·  SCHAUBILD</a:t>
-            </a:r>
-          </a:p>
-        </p:txBody>
-      </p:sp>
-      <p:sp>
-        <p:nvSpPr>
-          <p:cNvPr id="5" name="TextBox 4"/>
-          <p:cNvSpPr txBox="1"/>
-          <p:nvPr/>
-        </p:nvSpPr>
-        <p:spPr>
-          <a:xfrm>
-            <a:off x="685800" y="502920"/>
-            <a:ext cx="10817352" cy="594360"/>
-          </a:xfrm>
-          <a:prstGeom prst="rect">
-            <a:avLst/>
-          </a:prstGeom>
-          <a:noFill/>
-        </p:spPr>
-        <p:txBody>
-          <a:bodyPr wrap="square">
-            <a:spAutoFit/>
-          </a:bodyPr>
-          <a:lstStyle/>
-          <a:p>
-            <a:pPr algn="l"/>
-            <a:r>
-              <a:rPr sz="2000" b="1" i="0">
-                <a:solidFill>
-                  <a:srgbClr val="1F2C56"/>
-                </a:solidFill>
-                <a:latin typeface="Arial"/>
-              </a:rPr>
-              <a:t>SECI-Modell Wissensspirale nach Nonaka &amp; Takeuchi</a:t>
-            </a:r>
+              <a:t>M19  ·  INHALT</a:t>
+            </a:r>
+          </a:p>
+        </p:txBody>
+      </p:sp>
+      <p:sp>
+        <p:nvSpPr>
+          <p:cNvPr id="5" name="Rectangle 4"/>
+          <p:cNvSpPr/>
+          <p:nvPr/>
+        </p:nvSpPr>
+        <p:spPr>
+          <a:xfrm>
+            <a:off x="0" y="1234440"/>
+            <a:ext cx="12188952" cy="12700"/>
+          </a:xfrm>
+          <a:prstGeom prst="rect">
+            <a:avLst/>
+          </a:prstGeom>
+          <a:solidFill>
+            <a:srgbClr val="D8DFE4"/>
+          </a:solidFill>
+          <a:ln>
+            <a:noFill/>
+          </a:ln>
+        </p:spPr>
+        <p:style>
+          <a:lnRef idx="1">
+            <a:schemeClr val="accent1"/>
+          </a:lnRef>
+          <a:fillRef idx="3">
+            <a:schemeClr val="accent1"/>
+          </a:fillRef>
+          <a:effectRef idx="2">
+            <a:schemeClr val="accent1"/>
+          </a:effectRef>
+          <a:fontRef idx="minor">
+            <a:schemeClr val="lt1"/>
+          </a:fontRef>
+        </p:style>
+        <p:txBody>
+          <a:bodyPr rtlCol="0" anchor="ctr"/>
+          <a:lstStyle/>
+          <a:p>
+            <a:pPr algn="ctr"/>
           </a:p>
         </p:txBody>
       </p:sp>
@@ -9249,8 +8191,8 @@
         </p:nvSpPr>
         <p:spPr>
           <a:xfrm>
-            <a:off x="685800" y="1143000"/>
-            <a:ext cx="10817352" cy="25400"/>
+            <a:off x="685800" y="502920"/>
+            <a:ext cx="36576" cy="658368"/>
           </a:xfrm>
           <a:prstGeom prst="rect">
             <a:avLst/>
@@ -9284,33 +8226,124 @@
           </a:p>
         </p:txBody>
       </p:sp>
-      <p:pic>
-        <p:nvPicPr>
-          <p:cNvPr id="7" name="Picture 6" descr="image.png"/>
-          <p:cNvPicPr>
-            <a:picLocks noChangeAspect="1"/>
-          </p:cNvPicPr>
-          <p:nvPr/>
-        </p:nvPicPr>
-        <p:blipFill>
-          <a:blip r:embed="rId2"/>
-          <a:stretch>
-            <a:fillRect/>
-          </a:stretch>
-        </p:blipFill>
-        <p:spPr>
-          <a:xfrm>
-            <a:off x="2554863" y="1325880"/>
-            <a:ext cx="7079225" cy="4937760"/>
-          </a:xfrm>
-          <a:prstGeom prst="rect">
-            <a:avLst/>
-          </a:prstGeom>
-        </p:spPr>
-      </p:pic>
-      <p:sp>
-        <p:nvSpPr>
-          <p:cNvPr id="8" name="Rectangle 7"/>
+      <p:sp>
+        <p:nvSpPr>
+          <p:cNvPr id="7" name="TextBox 6"/>
+          <p:cNvSpPr txBox="1"/>
+          <p:nvPr/>
+        </p:nvSpPr>
+        <p:spPr>
+          <a:xfrm>
+            <a:off x="813816" y="502920"/>
+            <a:ext cx="10634472" cy="685800"/>
+          </a:xfrm>
+          <a:prstGeom prst="rect">
+            <a:avLst/>
+          </a:prstGeom>
+          <a:noFill/>
+        </p:spPr>
+        <p:txBody>
+          <a:bodyPr wrap="square">
+            <a:spAutoFit/>
+          </a:bodyPr>
+          <a:lstStyle/>
+          <a:p>
+            <a:pPr algn="l"/>
+            <a:r>
+              <a:rPr sz="2400" b="1" i="0">
+                <a:solidFill>
+                  <a:srgbClr val="1F2C56"/>
+                </a:solidFill>
+                <a:latin typeface="Arial"/>
+              </a:rPr>
+              <a:t>Wissen in einem Kopf ist ein Risiko</a:t>
+            </a:r>
+          </a:p>
+        </p:txBody>
+      </p:sp>
+      <p:sp>
+        <p:nvSpPr>
+          <p:cNvPr id="8" name="TextBox 7"/>
+          <p:cNvSpPr txBox="1"/>
+          <p:nvPr/>
+        </p:nvSpPr>
+        <p:spPr>
+          <a:xfrm>
+            <a:off x="685800" y="1417320"/>
+            <a:ext cx="10817352" cy="4892040"/>
+          </a:xfrm>
+          <a:prstGeom prst="rect">
+            <a:avLst/>
+          </a:prstGeom>
+          <a:noFill/>
+        </p:spPr>
+        <p:txBody>
+          <a:bodyPr wrap="square" anchor="ctr">
+            <a:spAutoFit/>
+          </a:bodyPr>
+          <a:lstStyle/>
+          <a:p>
+            <a:pPr marL="177800" indent="-177800">
+              <a:spcBef>
+                <a:spcPts val="600"/>
+              </a:spcBef>
+              <a:spcAft>
+                <a:spcPts val="200"/>
+              </a:spcAft>
+            </a:pPr>
+            <a:r>
+              <a:rPr sz="1200" i="1">
+                <a:solidFill>
+                  <a:srgbClr val="3D5466"/>
+                </a:solidFill>
+                <a:latin typeface="Arial"/>
+              </a:rPr>
+              <a:t>→  Wissen, das nur in einem Kopf liegt, ist ein Risiko – kein Vorsprung.</a:t>
+            </a:r>
+          </a:p>
+          <a:p>
+            <a:pPr marL="190500" indent="-190500">
+              <a:spcBef>
+                <a:spcPts val="400"/>
+              </a:spcBef>
+              <a:spcAft>
+                <a:spcPts val="200"/>
+              </a:spcAft>
+            </a:pPr>
+            <a:r>
+              <a:rPr sz="1300">
+                <a:solidFill>
+                  <a:srgbClr val="3D5466"/>
+                </a:solidFill>
+                <a:latin typeface="Arial"/>
+              </a:rPr>
+              <a:t>▸  Erst geteiltes Wissen macht das Team stärker als die Summe seiner Berater.</a:t>
+            </a:r>
+          </a:p>
+          <a:p>
+            <a:pPr marL="190500" indent="-190500">
+              <a:spcBef>
+                <a:spcPts val="400"/>
+              </a:spcBef>
+              <a:spcAft>
+                <a:spcPts val="200"/>
+              </a:spcAft>
+            </a:pPr>
+            <a:r>
+              <a:rPr sz="1300">
+                <a:solidFill>
+                  <a:srgbClr val="3D5466"/>
+                </a:solidFill>
+                <a:latin typeface="Arial"/>
+              </a:rPr>
+              <a:t>▸  Wissenstransfer ist Führungsaufgabe – er passiert nicht von selbst.</a:t>
+            </a:r>
+          </a:p>
+        </p:txBody>
+      </p:sp>
+      <p:sp>
+        <p:nvSpPr>
+          <p:cNvPr id="9" name="Rectangle 8"/>
           <p:cNvSpPr/>
           <p:nvPr/>
         </p:nvSpPr>
@@ -9353,7 +8386,7 @@
       </p:sp>
       <p:sp>
         <p:nvSpPr>
-          <p:cNvPr id="9" name="TextBox 8"/>
+          <p:cNvPr id="10" name="TextBox 9"/>
           <p:cNvSpPr txBox="1"/>
           <p:nvPr/>
         </p:nvSpPr>
@@ -9382,41 +8415,6 @@
                 <a:latin typeface="Consolas"/>
               </a:rPr>
               <a:t>FKB Campus  ·  M19</a:t>
-            </a:r>
-          </a:p>
-        </p:txBody>
-      </p:sp>
-      <p:sp>
-        <p:nvSpPr>
-          <p:cNvPr id="10" name="TextBox 9"/>
-          <p:cNvSpPr txBox="1"/>
-          <p:nvPr/>
-        </p:nvSpPr>
-        <p:spPr>
-          <a:xfrm>
-            <a:off x="7176211" y="6583680"/>
-            <a:ext cx="4326940" cy="256032"/>
-          </a:xfrm>
-          <a:prstGeom prst="rect">
-            <a:avLst/>
-          </a:prstGeom>
-          <a:noFill/>
-        </p:spPr>
-        <p:txBody>
-          <a:bodyPr wrap="none">
-            <a:spAutoFit/>
-          </a:bodyPr>
-          <a:lstStyle/>
-          <a:p>
-            <a:pPr algn="r"/>
-            <a:r>
-              <a:rPr sz="700">
-                <a:solidFill>
-                  <a:srgbClr val="A0B4D2"/>
-                </a:solidFill>
-                <a:latin typeface="Consolas"/>
-              </a:rPr>
-              <a:t>Schaubild</a:t>
             </a:r>
           </a:p>
         </p:txBody>
@@ -9454,7 +8452,7 @@
             <a:avLst/>
           </a:prstGeom>
           <a:solidFill>
-            <a:srgbClr val="FFFFFF"/>
+            <a:srgbClr val="EDEDF3"/>
           </a:solidFill>
           <a:ln>
             <a:noFill/>
@@ -9555,43 +8553,51 @@
                 </a:solidFill>
                 <a:latin typeface="Consolas"/>
               </a:rPr>
-              <a:t>M19  ·  SCHAUBILD</a:t>
-            </a:r>
-          </a:p>
-        </p:txBody>
-      </p:sp>
-      <p:sp>
-        <p:nvSpPr>
-          <p:cNvPr id="5" name="TextBox 4"/>
-          <p:cNvSpPr txBox="1"/>
-          <p:nvPr/>
-        </p:nvSpPr>
-        <p:spPr>
-          <a:xfrm>
-            <a:off x="685800" y="502920"/>
-            <a:ext cx="10817352" cy="594360"/>
-          </a:xfrm>
-          <a:prstGeom prst="rect">
-            <a:avLst/>
-          </a:prstGeom>
-          <a:noFill/>
-        </p:spPr>
-        <p:txBody>
-          <a:bodyPr wrap="square">
-            <a:spAutoFit/>
-          </a:bodyPr>
-          <a:lstStyle/>
-          <a:p>
-            <a:pPr algn="l"/>
-            <a:r>
-              <a:rPr sz="2000" b="1" i="0">
-                <a:solidFill>
-                  <a:srgbClr val="1F2C56"/>
-                </a:solidFill>
-                <a:latin typeface="Arial"/>
-              </a:rPr>
-              <a:t>Kolb-Lernzyklus</a:t>
-            </a:r>
+              <a:t>M19  ·  INHALT</a:t>
+            </a:r>
+          </a:p>
+        </p:txBody>
+      </p:sp>
+      <p:sp>
+        <p:nvSpPr>
+          <p:cNvPr id="5" name="Rectangle 4"/>
+          <p:cNvSpPr/>
+          <p:nvPr/>
+        </p:nvSpPr>
+        <p:spPr>
+          <a:xfrm>
+            <a:off x="0" y="1234440"/>
+            <a:ext cx="12188952" cy="12700"/>
+          </a:xfrm>
+          <a:prstGeom prst="rect">
+            <a:avLst/>
+          </a:prstGeom>
+          <a:solidFill>
+            <a:srgbClr val="D8DFE4"/>
+          </a:solidFill>
+          <a:ln>
+            <a:noFill/>
+          </a:ln>
+        </p:spPr>
+        <p:style>
+          <a:lnRef idx="1">
+            <a:schemeClr val="accent1"/>
+          </a:lnRef>
+          <a:fillRef idx="3">
+            <a:schemeClr val="accent1"/>
+          </a:fillRef>
+          <a:effectRef idx="2">
+            <a:schemeClr val="accent1"/>
+          </a:effectRef>
+          <a:fontRef idx="minor">
+            <a:schemeClr val="lt1"/>
+          </a:fontRef>
+        </p:style>
+        <p:txBody>
+          <a:bodyPr rtlCol="0" anchor="ctr"/>
+          <a:lstStyle/>
+          <a:p>
+            <a:pPr algn="ctr"/>
           </a:p>
         </p:txBody>
       </p:sp>
@@ -9603,8 +8609,8 @@
         </p:nvSpPr>
         <p:spPr>
           <a:xfrm>
-            <a:off x="685800" y="1143000"/>
-            <a:ext cx="10817352" cy="25400"/>
+            <a:off x="685800" y="502920"/>
+            <a:ext cx="36576" cy="658368"/>
           </a:xfrm>
           <a:prstGeom prst="rect">
             <a:avLst/>
@@ -9638,33 +8644,124 @@
           </a:p>
         </p:txBody>
       </p:sp>
-      <p:pic>
-        <p:nvPicPr>
-          <p:cNvPr id="7" name="Picture 6" descr="image.png"/>
-          <p:cNvPicPr>
-            <a:picLocks noChangeAspect="1"/>
-          </p:cNvPicPr>
-          <p:nvPr/>
-        </p:nvPicPr>
-        <p:blipFill>
-          <a:blip r:embed="rId2"/>
-          <a:stretch>
-            <a:fillRect/>
-          </a:stretch>
-        </p:blipFill>
-        <p:spPr>
-          <a:xfrm>
-            <a:off x="2554863" y="1325880"/>
-            <a:ext cx="7079225" cy="4937760"/>
-          </a:xfrm>
-          <a:prstGeom prst="rect">
-            <a:avLst/>
-          </a:prstGeom>
-        </p:spPr>
-      </p:pic>
-      <p:sp>
-        <p:nvSpPr>
-          <p:cNvPr id="8" name="Rectangle 7"/>
+      <p:sp>
+        <p:nvSpPr>
+          <p:cNvPr id="7" name="TextBox 6"/>
+          <p:cNvSpPr txBox="1"/>
+          <p:nvPr/>
+        </p:nvSpPr>
+        <p:spPr>
+          <a:xfrm>
+            <a:off x="813816" y="502920"/>
+            <a:ext cx="10634472" cy="685800"/>
+          </a:xfrm>
+          <a:prstGeom prst="rect">
+            <a:avLst/>
+          </a:prstGeom>
+          <a:noFill/>
+        </p:spPr>
+        <p:txBody>
+          <a:bodyPr wrap="square">
+            <a:spAutoFit/>
+          </a:bodyPr>
+          <a:lstStyle/>
+          <a:p>
+            <a:pPr algn="l"/>
+            <a:r>
+              <a:rPr sz="2400" b="1" i="0">
+                <a:solidFill>
+                  <a:srgbClr val="1F2C56"/>
+                </a:solidFill>
+                <a:latin typeface="Arial"/>
+              </a:rPr>
+              <a:t>Wie Wissen im Team entsteht: das SECI-Modell</a:t>
+            </a:r>
+          </a:p>
+        </p:txBody>
+      </p:sp>
+      <p:sp>
+        <p:nvSpPr>
+          <p:cNvPr id="8" name="TextBox 7"/>
+          <p:cNvSpPr txBox="1"/>
+          <p:nvPr/>
+        </p:nvSpPr>
+        <p:spPr>
+          <a:xfrm>
+            <a:off x="685800" y="1417320"/>
+            <a:ext cx="10817352" cy="4892040"/>
+          </a:xfrm>
+          <a:prstGeom prst="rect">
+            <a:avLst/>
+          </a:prstGeom>
+          <a:noFill/>
+        </p:spPr>
+        <p:txBody>
+          <a:bodyPr wrap="square" anchor="ctr">
+            <a:spAutoFit/>
+          </a:bodyPr>
+          <a:lstStyle/>
+          <a:p>
+            <a:pPr marL="177800" indent="-177800">
+              <a:spcBef>
+                <a:spcPts val="600"/>
+              </a:spcBef>
+              <a:spcAft>
+                <a:spcPts val="200"/>
+              </a:spcAft>
+            </a:pPr>
+            <a:r>
+              <a:rPr sz="1200" i="1">
+                <a:solidFill>
+                  <a:srgbClr val="3D5466"/>
+                </a:solidFill>
+                <a:latin typeface="Arial"/>
+              </a:rPr>
+              <a:t>→  Wissen entsteht in der Spirale aus implizit und explizit – Sozialisation, Externalisierung, Kombination, Internalisierung.</a:t>
+            </a:r>
+          </a:p>
+          <a:p>
+            <a:pPr marL="190500" indent="-190500">
+              <a:spcBef>
+                <a:spcPts val="400"/>
+              </a:spcBef>
+              <a:spcAft>
+                <a:spcPts val="200"/>
+              </a:spcAft>
+            </a:pPr>
+            <a:r>
+              <a:rPr sz="1300">
+                <a:solidFill>
+                  <a:srgbClr val="3D5466"/>
+                </a:solidFill>
+                <a:latin typeface="Arial"/>
+              </a:rPr>
+              <a:t>▸  Implizites Erfahrungswissen wird durch Teilen explizit und wieder verinnerlicht.</a:t>
+            </a:r>
+          </a:p>
+          <a:p>
+            <a:pPr marL="190500" indent="-190500">
+              <a:spcBef>
+                <a:spcPts val="400"/>
+              </a:spcBef>
+              <a:spcAft>
+                <a:spcPts val="200"/>
+              </a:spcAft>
+            </a:pPr>
+            <a:r>
+              <a:rPr sz="1300">
+                <a:solidFill>
+                  <a:srgbClr val="3D5466"/>
+                </a:solidFill>
+                <a:latin typeface="Arial"/>
+              </a:rPr>
+              <a:t>▸  Communities of Practice machen das Team zur Lerngemeinschaft.</a:t>
+            </a:r>
+          </a:p>
+        </p:txBody>
+      </p:sp>
+      <p:sp>
+        <p:nvSpPr>
+          <p:cNvPr id="9" name="Rectangle 8"/>
           <p:cNvSpPr/>
           <p:nvPr/>
         </p:nvSpPr>
@@ -9707,7 +8804,7 @@
       </p:sp>
       <p:sp>
         <p:nvSpPr>
-          <p:cNvPr id="9" name="TextBox 8"/>
+          <p:cNvPr id="10" name="TextBox 9"/>
           <p:cNvSpPr txBox="1"/>
           <p:nvPr/>
         </p:nvSpPr>
@@ -9736,41 +8833,6 @@
                 <a:latin typeface="Consolas"/>
               </a:rPr>
               <a:t>FKB Campus  ·  M19</a:t>
-            </a:r>
-          </a:p>
-        </p:txBody>
-      </p:sp>
-      <p:sp>
-        <p:nvSpPr>
-          <p:cNvPr id="10" name="TextBox 9"/>
-          <p:cNvSpPr txBox="1"/>
-          <p:nvPr/>
-        </p:nvSpPr>
-        <p:spPr>
-          <a:xfrm>
-            <a:off x="7176211" y="6583680"/>
-            <a:ext cx="4326940" cy="256032"/>
-          </a:xfrm>
-          <a:prstGeom prst="rect">
-            <a:avLst/>
-          </a:prstGeom>
-          <a:noFill/>
-        </p:spPr>
-        <p:txBody>
-          <a:bodyPr wrap="none">
-            <a:spAutoFit/>
-          </a:bodyPr>
-          <a:lstStyle/>
-          <a:p>
-            <a:pPr algn="r"/>
-            <a:r>
-              <a:rPr sz="700">
-                <a:solidFill>
-                  <a:srgbClr val="A0B4D2"/>
-                </a:solidFill>
-                <a:latin typeface="Consolas"/>
-              </a:rPr>
-              <a:t>Schaubild</a:t>
             </a:r>
           </a:p>
         </p:txBody>
@@ -9808,7 +8870,7 @@
             <a:avLst/>
           </a:prstGeom>
           <a:solidFill>
-            <a:srgbClr val="EDEDF3"/>
+            <a:srgbClr val="FFFFFF"/>
           </a:solidFill>
           <a:ln>
             <a:noFill/>
@@ -9909,51 +8971,43 @@
                 </a:solidFill>
                 <a:latin typeface="Consolas"/>
               </a:rPr>
-              <a:t>M19  ·  INHALT</a:t>
-            </a:r>
-          </a:p>
-        </p:txBody>
-      </p:sp>
-      <p:sp>
-        <p:nvSpPr>
-          <p:cNvPr id="5" name="Rectangle 4"/>
-          <p:cNvSpPr/>
-          <p:nvPr/>
-        </p:nvSpPr>
-        <p:spPr>
-          <a:xfrm>
-            <a:off x="0" y="1234440"/>
-            <a:ext cx="12188952" cy="12700"/>
-          </a:xfrm>
-          <a:prstGeom prst="rect">
-            <a:avLst/>
-          </a:prstGeom>
-          <a:solidFill>
-            <a:srgbClr val="D8DFE4"/>
-          </a:solidFill>
-          <a:ln>
-            <a:noFill/>
-          </a:ln>
-        </p:spPr>
-        <p:style>
-          <a:lnRef idx="1">
-            <a:schemeClr val="accent1"/>
-          </a:lnRef>
-          <a:fillRef idx="3">
-            <a:schemeClr val="accent1"/>
-          </a:fillRef>
-          <a:effectRef idx="2">
-            <a:schemeClr val="accent1"/>
-          </a:effectRef>
-          <a:fontRef idx="minor">
-            <a:schemeClr val="lt1"/>
-          </a:fontRef>
-        </p:style>
-        <p:txBody>
-          <a:bodyPr rtlCol="0" anchor="ctr"/>
-          <a:lstStyle/>
-          <a:p>
-            <a:pPr algn="ctr"/>
+              <a:t>M19  ·  SCHAUBILD</a:t>
+            </a:r>
+          </a:p>
+        </p:txBody>
+      </p:sp>
+      <p:sp>
+        <p:nvSpPr>
+          <p:cNvPr id="5" name="TextBox 4"/>
+          <p:cNvSpPr txBox="1"/>
+          <p:nvPr/>
+        </p:nvSpPr>
+        <p:spPr>
+          <a:xfrm>
+            <a:off x="685800" y="502920"/>
+            <a:ext cx="10817352" cy="594360"/>
+          </a:xfrm>
+          <a:prstGeom prst="rect">
+            <a:avLst/>
+          </a:prstGeom>
+          <a:noFill/>
+        </p:spPr>
+        <p:txBody>
+          <a:bodyPr wrap="square">
+            <a:spAutoFit/>
+          </a:bodyPr>
+          <a:lstStyle/>
+          <a:p>
+            <a:pPr algn="l"/>
+            <a:r>
+              <a:rPr sz="2000" b="1" i="0">
+                <a:solidFill>
+                  <a:srgbClr val="1F2C56"/>
+                </a:solidFill>
+                <a:latin typeface="Arial"/>
+              </a:rPr>
+              <a:t>Das SECI-Modell der Wissensspirale</a:t>
+            </a:r>
           </a:p>
         </p:txBody>
       </p:sp>
@@ -9965,8 +9019,8 @@
         </p:nvSpPr>
         <p:spPr>
           <a:xfrm>
-            <a:off x="685800" y="502920"/>
-            <a:ext cx="36576" cy="658368"/>
+            <a:off x="685800" y="1143000"/>
+            <a:ext cx="10817352" cy="25400"/>
           </a:xfrm>
           <a:prstGeom prst="rect">
             <a:avLst/>
@@ -10000,200 +9054,33 @@
           </a:p>
         </p:txBody>
       </p:sp>
-      <p:sp>
-        <p:nvSpPr>
-          <p:cNvPr id="7" name="TextBox 6"/>
-          <p:cNvSpPr txBox="1"/>
-          <p:nvPr/>
-        </p:nvSpPr>
-        <p:spPr>
-          <a:xfrm>
-            <a:off x="813816" y="502920"/>
-            <a:ext cx="10634472" cy="685800"/>
-          </a:xfrm>
-          <a:prstGeom prst="rect">
-            <a:avLst/>
-          </a:prstGeom>
-          <a:noFill/>
-        </p:spPr>
-        <p:txBody>
-          <a:bodyPr wrap="square">
-            <a:spAutoFit/>
-          </a:bodyPr>
-          <a:lstStyle/>
-          <a:p>
-            <a:pPr algn="l"/>
-            <a:r>
-              <a:rPr sz="2400" b="1" i="0">
-                <a:solidFill>
-                  <a:srgbClr val="1F2C56"/>
-                </a:solidFill>
-                <a:latin typeface="Arial"/>
-              </a:rPr>
-              <a:t>Methode 1: Tandem-Kundenbesuch</a:t>
-            </a:r>
-          </a:p>
-        </p:txBody>
-      </p:sp>
-      <p:sp>
-        <p:nvSpPr>
-          <p:cNvPr id="8" name="TextBox 7"/>
-          <p:cNvSpPr txBox="1"/>
-          <p:nvPr/>
-        </p:nvSpPr>
-        <p:spPr>
-          <a:xfrm>
-            <a:off x="685800" y="1417320"/>
-            <a:ext cx="10817352" cy="4892040"/>
-          </a:xfrm>
-          <a:prstGeom prst="rect">
-            <a:avLst/>
-          </a:prstGeom>
-          <a:noFill/>
-        </p:spPr>
-        <p:txBody>
-          <a:bodyPr wrap="square">
-            <a:spAutoFit/>
-          </a:bodyPr>
-          <a:lstStyle/>
-          <a:p>
-            <a:pPr marL="190500" indent="-190500">
-              <a:spcBef>
-                <a:spcPts val="400"/>
-              </a:spcBef>
-              <a:spcAft>
-                <a:spcPts val="200"/>
-              </a:spcAft>
-            </a:pPr>
-            <a:r>
-              <a:rPr sz="1300">
-                <a:solidFill>
-                  <a:srgbClr val="3D5466"/>
-                </a:solidFill>
-                <a:latin typeface="Arial"/>
-              </a:rPr>
-              <a:t>▸  Was: Zwei Berater besuchen gemeinsam einen Kunden – einer führt, einer beobachtet.</a:t>
-            </a:r>
-          </a:p>
-          <a:p>
-            <a:pPr marL="190500" indent="-190500">
-              <a:spcBef>
-                <a:spcPts val="400"/>
-              </a:spcBef>
-              <a:spcAft>
-                <a:spcPts val="200"/>
-              </a:spcAft>
-            </a:pPr>
-            <a:r>
-              <a:rPr sz="1300">
-                <a:solidFill>
-                  <a:srgbClr val="3D5466"/>
-                </a:solidFill>
-                <a:latin typeface="Arial"/>
-              </a:rPr>
-              <a:t>▸  Wann: Bei speziellem Branchenwissen oder neuem Kundensegment.</a:t>
-            </a:r>
-          </a:p>
-          <a:p>
-            <a:pPr marL="190500" indent="-190500">
-              <a:spcBef>
-                <a:spcPts val="400"/>
-              </a:spcBef>
-              <a:spcAft>
-                <a:spcPts val="200"/>
-              </a:spcAft>
-            </a:pPr>
-            <a:r>
-              <a:rPr sz="1300">
-                <a:solidFill>
-                  <a:srgbClr val="3D5466"/>
-                </a:solidFill>
-                <a:latin typeface="Arial"/>
-              </a:rPr>
-              <a:t>▸  Ablauf:</a:t>
-            </a:r>
-          </a:p>
-          <a:p>
-            <a:pPr marL="190500" indent="-190500">
-              <a:spcBef>
-                <a:spcPts val="400"/>
-              </a:spcBef>
-              <a:spcAft>
-                <a:spcPts val="200"/>
-              </a:spcAft>
-            </a:pPr>
-            <a:r>
-              <a:rPr sz="1300">
-                <a:solidFill>
-                  <a:srgbClr val="3D5466"/>
-                </a:solidFill>
-                <a:latin typeface="Arial"/>
-              </a:rPr>
-              <a:t>▸  Kurze Vorbesprechung (10 Min.): Wer übernimmt welche Rolle? Welche Beobachtungsaufgabe hat der Gast?</a:t>
-            </a:r>
-          </a:p>
-          <a:p>
-            <a:pPr marL="190500" indent="-190500">
-              <a:spcBef>
-                <a:spcPts val="400"/>
-              </a:spcBef>
-              <a:spcAft>
-                <a:spcPts val="200"/>
-              </a:spcAft>
-            </a:pPr>
-            <a:r>
-              <a:rPr sz="1300">
-                <a:solidFill>
-                  <a:srgbClr val="3D5466"/>
-                </a:solidFill>
-                <a:latin typeface="Arial"/>
-              </a:rPr>
-              <a:t>▸  Kundenbesuch (gemeinsam, einer führt)</a:t>
-            </a:r>
-          </a:p>
-          <a:p>
-            <a:pPr marL="190500" indent="-190500">
-              <a:spcBef>
-                <a:spcPts val="400"/>
-              </a:spcBef>
-              <a:spcAft>
-                <a:spcPts val="200"/>
-              </a:spcAft>
-            </a:pPr>
-            <a:r>
-              <a:rPr sz="1300">
-                <a:solidFill>
-                  <a:srgbClr val="3D5466"/>
-                </a:solidFill>
-                <a:latin typeface="Arial"/>
-              </a:rPr>
-              <a:t>▸  Nachbesprechung (15 Min.): Beobachter gibt strukturiertes Feedback; Berater teilt Hintergrundwissen</a:t>
-            </a:r>
-          </a:p>
-          <a:p>
-            <a:pPr marL="190500" indent="-190500">
-              <a:spcBef>
-                <a:spcPts val="400"/>
-              </a:spcBef>
-              <a:spcAft>
-                <a:spcPts val="200"/>
-              </a:spcAft>
-            </a:pPr>
-            <a:r>
-              <a:rPr sz="1300">
-                <a:solidFill>
-                  <a:srgbClr val="3D5466"/>
-                </a:solidFill>
-                <a:latin typeface="Arial"/>
-              </a:rPr>
-              <a:t>▸  Qualitätsfaktor: Der Beobachter hat vorab eine konkrete Beobachtungsaufgabe (z.B. „achte auf, wie der Kollege das Thema Nachfolge einführt").</a:t>
-            </a:r>
-          </a:p>
-        </p:txBody>
-      </p:sp>
-      <p:sp>
-        <p:nvSpPr>
-          <p:cNvPr id="9" name="Rectangle 8"/>
+      <p:pic>
+        <p:nvPicPr>
+          <p:cNvPr id="7" name="Picture 6" descr="image.png"/>
+          <p:cNvPicPr>
+            <a:picLocks noChangeAspect="1"/>
+          </p:cNvPicPr>
+          <p:nvPr/>
+        </p:nvPicPr>
+        <p:blipFill>
+          <a:blip r:embed="rId2"/>
+          <a:stretch>
+            <a:fillRect/>
+          </a:stretch>
+        </p:blipFill>
+        <p:spPr>
+          <a:xfrm>
+            <a:off x="2554863" y="1325880"/>
+            <a:ext cx="7079225" cy="4937760"/>
+          </a:xfrm>
+          <a:prstGeom prst="rect">
+            <a:avLst/>
+          </a:prstGeom>
+        </p:spPr>
+      </p:pic>
+      <p:sp>
+        <p:nvSpPr>
+          <p:cNvPr id="8" name="Rectangle 7"/>
           <p:cNvSpPr/>
           <p:nvPr/>
         </p:nvSpPr>
@@ -10236,7 +9123,7 @@
       </p:sp>
       <p:sp>
         <p:nvSpPr>
-          <p:cNvPr id="10" name="TextBox 9"/>
+          <p:cNvPr id="9" name="TextBox 8"/>
           <p:cNvSpPr txBox="1"/>
           <p:nvPr/>
         </p:nvSpPr>
@@ -10265,6 +9152,41 @@
                 <a:latin typeface="Consolas"/>
               </a:rPr>
               <a:t>FKB Campus  ·  M19</a:t>
+            </a:r>
+          </a:p>
+        </p:txBody>
+      </p:sp>
+      <p:sp>
+        <p:nvSpPr>
+          <p:cNvPr id="10" name="TextBox 9"/>
+          <p:cNvSpPr txBox="1"/>
+          <p:nvPr/>
+        </p:nvSpPr>
+        <p:spPr>
+          <a:xfrm>
+            <a:off x="7176211" y="6583680"/>
+            <a:ext cx="4326940" cy="256032"/>
+          </a:xfrm>
+          <a:prstGeom prst="rect">
+            <a:avLst/>
+          </a:prstGeom>
+          <a:noFill/>
+        </p:spPr>
+        <p:txBody>
+          <a:bodyPr wrap="none">
+            <a:spAutoFit/>
+          </a:bodyPr>
+          <a:lstStyle/>
+          <a:p>
+            <a:pPr algn="r"/>
+            <a:r>
+              <a:rPr sz="700">
+                <a:solidFill>
+                  <a:srgbClr val="A0B4D2"/>
+                </a:solidFill>
+                <a:latin typeface="Consolas"/>
+              </a:rPr>
+              <a:t>Schaubild</a:t>
             </a:r>
           </a:p>
         </p:txBody>
@@ -10524,7 +9446,7 @@
                 </a:solidFill>
                 <a:latin typeface="Arial"/>
               </a:rPr>
-              <a:t>Methode 2: Strukturierte Fallbesprechung</a:t>
+              <a:t>Wie Erfahrung zu Wissen wird: Kolbs Lernzyklus</a:t>
             </a:r>
           </a:p>
         </p:txBody>
@@ -10550,6 +9472,25 @@
             <a:spAutoFit/>
           </a:bodyPr>
           <a:lstStyle/>
+          <a:p>
+            <a:pPr marL="177800" indent="-177800">
+              <a:spcBef>
+                <a:spcPts val="600"/>
+              </a:spcBef>
+              <a:spcAft>
+                <a:spcPts val="200"/>
+              </a:spcAft>
+            </a:pPr>
+            <a:r>
+              <a:rPr sz="1200" i="1">
+                <a:solidFill>
+                  <a:srgbClr val="3D5466"/>
+                </a:solidFill>
+                <a:latin typeface="Arial"/>
+              </a:rPr>
+              <a:t>→  Erfahrung wird erst durch Reflexion zu Wissen – wer nur erlebt, ohne zu reflektieren, lernt nicht.</a:t>
+            </a:r>
+          </a:p>
           <a:p>
             <a:pPr marL="190500" indent="-190500">
               <a:spcBef>
@@ -10566,7 +9507,7 @@
                 </a:solidFill>
                 <a:latin typeface="Arial"/>
               </a:rPr>
-              <a:t>▸  Was: 45-minütiges Team-Format, in dem ein Berater einen aktuellen Fall vorstellt und das Team kollektiv reflektiert.</a:t>
+              <a:t>▸  Erfahren, beobachten/reflektieren, verstehen, ausprobieren.</a:t>
             </a:r>
           </a:p>
           <a:p>
@@ -10585,26 +9526,7 @@
                 </a:solidFill>
                 <a:latin typeface="Arial"/>
               </a:rPr>
-              <a:t>▸  Struktur:</a:t>
-            </a:r>
-          </a:p>
-          <a:p>
-            <a:pPr marL="190500" indent="-190500">
-              <a:spcBef>
-                <a:spcPts val="400"/>
-              </a:spcBef>
-              <a:spcAft>
-                <a:spcPts val="200"/>
-              </a:spcAft>
-            </a:pPr>
-            <a:r>
-              <a:rPr sz="1300">
-                <a:solidFill>
-                  <a:srgbClr val="3D5466"/>
-                </a:solidFill>
-                <a:latin typeface="Arial"/>
-              </a:rPr>
-              <a:t>▸  Qualitätsfaktor: Die stille Reflexion vor der Diskussion verhindert Gruppendenken (Anchoring-Bias).</a:t>
+              <a:t>▸  Der Zyklus ist der Motor jeder wirksamen Transfermethode.</a:t>
             </a:r>
           </a:p>
         </p:txBody>
@@ -10720,7 +9642,7 @@
             <a:avLst/>
           </a:prstGeom>
           <a:solidFill>
-            <a:srgbClr val="EDEDF3"/>
+            <a:srgbClr val="FFFFFF"/>
           </a:solidFill>
           <a:ln>
             <a:noFill/>
@@ -10821,51 +9743,43 @@
                 </a:solidFill>
                 <a:latin typeface="Consolas"/>
               </a:rPr>
-              <a:t>M19  ·  INHALT</a:t>
-            </a:r>
-          </a:p>
-        </p:txBody>
-      </p:sp>
-      <p:sp>
-        <p:nvSpPr>
-          <p:cNvPr id="5" name="Rectangle 4"/>
-          <p:cNvSpPr/>
-          <p:nvPr/>
-        </p:nvSpPr>
-        <p:spPr>
-          <a:xfrm>
-            <a:off x="0" y="1234440"/>
-            <a:ext cx="12188952" cy="12700"/>
-          </a:xfrm>
-          <a:prstGeom prst="rect">
-            <a:avLst/>
-          </a:prstGeom>
-          <a:solidFill>
-            <a:srgbClr val="D8DFE4"/>
-          </a:solidFill>
-          <a:ln>
-            <a:noFill/>
-          </a:ln>
-        </p:spPr>
-        <p:style>
-          <a:lnRef idx="1">
-            <a:schemeClr val="accent1"/>
-          </a:lnRef>
-          <a:fillRef idx="3">
-            <a:schemeClr val="accent1"/>
-          </a:fillRef>
-          <a:effectRef idx="2">
-            <a:schemeClr val="accent1"/>
-          </a:effectRef>
-          <a:fontRef idx="minor">
-            <a:schemeClr val="lt1"/>
-          </a:fontRef>
-        </p:style>
-        <p:txBody>
-          <a:bodyPr rtlCol="0" anchor="ctr"/>
-          <a:lstStyle/>
-          <a:p>
-            <a:pPr algn="ctr"/>
+              <a:t>M19  ·  SCHAUBILD</a:t>
+            </a:r>
+          </a:p>
+        </p:txBody>
+      </p:sp>
+      <p:sp>
+        <p:nvSpPr>
+          <p:cNvPr id="5" name="TextBox 4"/>
+          <p:cNvSpPr txBox="1"/>
+          <p:nvPr/>
+        </p:nvSpPr>
+        <p:spPr>
+          <a:xfrm>
+            <a:off x="685800" y="502920"/>
+            <a:ext cx="10817352" cy="594360"/>
+          </a:xfrm>
+          <a:prstGeom prst="rect">
+            <a:avLst/>
+          </a:prstGeom>
+          <a:noFill/>
+        </p:spPr>
+        <p:txBody>
+          <a:bodyPr wrap="square">
+            <a:spAutoFit/>
+          </a:bodyPr>
+          <a:lstStyle/>
+          <a:p>
+            <a:pPr algn="l"/>
+            <a:r>
+              <a:rPr sz="2000" b="1" i="0">
+                <a:solidFill>
+                  <a:srgbClr val="1F2C56"/>
+                </a:solidFill>
+                <a:latin typeface="Arial"/>
+              </a:rPr>
+              <a:t>Kolbs Lernzyklus</a:t>
+            </a:r>
           </a:p>
         </p:txBody>
       </p:sp>
@@ -10877,8 +9791,8 @@
         </p:nvSpPr>
         <p:spPr>
           <a:xfrm>
-            <a:off x="685800" y="502920"/>
-            <a:ext cx="36576" cy="658368"/>
+            <a:off x="685800" y="1143000"/>
+            <a:ext cx="10817352" cy="25400"/>
           </a:xfrm>
           <a:prstGeom prst="rect">
             <a:avLst/>
@@ -10912,143 +9826,33 @@
           </a:p>
         </p:txBody>
       </p:sp>
-      <p:sp>
-        <p:nvSpPr>
-          <p:cNvPr id="7" name="TextBox 6"/>
-          <p:cNvSpPr txBox="1"/>
-          <p:nvPr/>
-        </p:nvSpPr>
-        <p:spPr>
-          <a:xfrm>
-            <a:off x="813816" y="502920"/>
-            <a:ext cx="10634472" cy="685800"/>
-          </a:xfrm>
-          <a:prstGeom prst="rect">
-            <a:avLst/>
-          </a:prstGeom>
-          <a:noFill/>
-        </p:spPr>
-        <p:txBody>
-          <a:bodyPr wrap="square">
-            <a:spAutoFit/>
-          </a:bodyPr>
-          <a:lstStyle/>
-          <a:p>
-            <a:pPr algn="l"/>
-            <a:r>
-              <a:rPr sz="2400" b="1" i="0">
-                <a:solidFill>
-                  <a:srgbClr val="1F2C56"/>
-                </a:solidFill>
-                <a:latin typeface="Arial"/>
-              </a:rPr>
-              <a:t>Methode 3: Wissenslandkarte</a:t>
-            </a:r>
-          </a:p>
-        </p:txBody>
-      </p:sp>
-      <p:sp>
-        <p:nvSpPr>
-          <p:cNvPr id="8" name="TextBox 7"/>
-          <p:cNvSpPr txBox="1"/>
-          <p:nvPr/>
-        </p:nvSpPr>
-        <p:spPr>
-          <a:xfrm>
-            <a:off x="685800" y="1417320"/>
-            <a:ext cx="10817352" cy="4892040"/>
-          </a:xfrm>
-          <a:prstGeom prst="rect">
-            <a:avLst/>
-          </a:prstGeom>
-          <a:noFill/>
-        </p:spPr>
-        <p:txBody>
-          <a:bodyPr wrap="square" anchor="ctr">
-            <a:spAutoFit/>
-          </a:bodyPr>
-          <a:lstStyle/>
-          <a:p>
-            <a:pPr marL="190500" indent="-190500">
-              <a:spcBef>
-                <a:spcPts val="400"/>
-              </a:spcBef>
-              <a:spcAft>
-                <a:spcPts val="200"/>
-              </a:spcAft>
-            </a:pPr>
-            <a:r>
-              <a:rPr sz="1300">
-                <a:solidFill>
-                  <a:srgbClr val="3D5466"/>
-                </a:solidFill>
-                <a:latin typeface="Arial"/>
-              </a:rPr>
-              <a:t>▸  Was: Visualisierung, wer im Team über welches Spezialwissen verfügt.</a:t>
-            </a:r>
-          </a:p>
-          <a:p>
-            <a:pPr marL="190500" indent="-190500">
-              <a:spcBef>
-                <a:spcPts val="400"/>
-              </a:spcBef>
-              <a:spcAft>
-                <a:spcPts val="200"/>
-              </a:spcAft>
-            </a:pPr>
-            <a:r>
-              <a:rPr sz="1300">
-                <a:solidFill>
-                  <a:srgbClr val="3D5466"/>
-                </a:solidFill>
-                <a:latin typeface="Arial"/>
-              </a:rPr>
-              <a:t>▸  Wann: Einmalig erstellen, halbjährlich aktualisieren.</a:t>
-            </a:r>
-          </a:p>
-          <a:p>
-            <a:pPr marL="190500" indent="-190500">
-              <a:spcBef>
-                <a:spcPts val="400"/>
-              </a:spcBef>
-              <a:spcAft>
-                <a:spcPts val="200"/>
-              </a:spcAft>
-            </a:pPr>
-            <a:r>
-              <a:rPr sz="1300">
-                <a:solidFill>
-                  <a:srgbClr val="3D5466"/>
-                </a:solidFill>
-                <a:latin typeface="Arial"/>
-              </a:rPr>
-              <a:t>▸  Inhalt: Pro Berater: Branchenexpertise, Sonderwissen (z.B. Nachfolge, Landwirtschaft, Heilberufe), bevorzugte Methoden, Kontaktnetzwerk.</a:t>
-            </a:r>
-          </a:p>
-          <a:p>
-            <a:pPr marL="190500" indent="-190500">
-              <a:spcBef>
-                <a:spcPts val="400"/>
-              </a:spcBef>
-              <a:spcAft>
-                <a:spcPts val="200"/>
-              </a:spcAft>
-            </a:pPr>
-            <a:r>
-              <a:rPr sz="1300">
-                <a:solidFill>
-                  <a:srgbClr val="3D5466"/>
-                </a:solidFill>
-                <a:latin typeface="Arial"/>
-              </a:rPr>
-              <a:t>▸  Nutzen: Neue Berater wissen sofort, wen sie bei welchem Thema fragen sollen. Der Teamleiter erkennt Wissensinseln und -lücken.</a:t>
-            </a:r>
-          </a:p>
-        </p:txBody>
-      </p:sp>
-      <p:sp>
-        <p:nvSpPr>
-          <p:cNvPr id="9" name="Rectangle 8"/>
+      <p:pic>
+        <p:nvPicPr>
+          <p:cNvPr id="7" name="Picture 6" descr="image.png"/>
+          <p:cNvPicPr>
+            <a:picLocks noChangeAspect="1"/>
+          </p:cNvPicPr>
+          <p:nvPr/>
+        </p:nvPicPr>
+        <p:blipFill>
+          <a:blip r:embed="rId2"/>
+          <a:stretch>
+            <a:fillRect/>
+          </a:stretch>
+        </p:blipFill>
+        <p:spPr>
+          <a:xfrm>
+            <a:off x="2554863" y="1325880"/>
+            <a:ext cx="7079225" cy="4937760"/>
+          </a:xfrm>
+          <a:prstGeom prst="rect">
+            <a:avLst/>
+          </a:prstGeom>
+        </p:spPr>
+      </p:pic>
+      <p:sp>
+        <p:nvSpPr>
+          <p:cNvPr id="8" name="Rectangle 7"/>
           <p:cNvSpPr/>
           <p:nvPr/>
         </p:nvSpPr>
@@ -11091,7 +9895,7 @@
       </p:sp>
       <p:sp>
         <p:nvSpPr>
-          <p:cNvPr id="10" name="TextBox 9"/>
+          <p:cNvPr id="9" name="TextBox 8"/>
           <p:cNvSpPr txBox="1"/>
           <p:nvPr/>
         </p:nvSpPr>
@@ -11120,6 +9924,41 @@
                 <a:latin typeface="Consolas"/>
               </a:rPr>
               <a:t>FKB Campus  ·  M19</a:t>
+            </a:r>
+          </a:p>
+        </p:txBody>
+      </p:sp>
+      <p:sp>
+        <p:nvSpPr>
+          <p:cNvPr id="10" name="TextBox 9"/>
+          <p:cNvSpPr txBox="1"/>
+          <p:nvPr/>
+        </p:nvSpPr>
+        <p:spPr>
+          <a:xfrm>
+            <a:off x="7176211" y="6583680"/>
+            <a:ext cx="4326940" cy="256032"/>
+          </a:xfrm>
+          <a:prstGeom prst="rect">
+            <a:avLst/>
+          </a:prstGeom>
+          <a:noFill/>
+        </p:spPr>
+        <p:txBody>
+          <a:bodyPr wrap="none">
+            <a:spAutoFit/>
+          </a:bodyPr>
+          <a:lstStyle/>
+          <a:p>
+            <a:pPr algn="r"/>
+            <a:r>
+              <a:rPr sz="700">
+                <a:solidFill>
+                  <a:srgbClr val="A0B4D2"/>
+                </a:solidFill>
+                <a:latin typeface="Consolas"/>
+              </a:rPr>
+              <a:t>Schaubild</a:t>
             </a:r>
           </a:p>
         </p:txBody>

</xml_diff>